<commit_message>
M2: implement Pareto method kit
Validation:

- .venv/bin/python -m pytest tests/test_method_guides.py tests/test_template_assets.py tests/test_template_catalog.py

- .venv/bin/python tools/build_ppt_templates.py

- .venv/bin/python -m qcc_toolkit.templates validate templates/ppt/catalog.yml

- .venv/bin/python -m ruff check .

- .venv/bin/python -m mypy qcc_toolkit

- MP1 manual review recorded in docs/changes/2026-07-08-improve-qcc-method-templates/manual-template-review.md
</commit_message>
<xml_diff>
--- a/templates/ppt/methods/pareto-chart-template.pptx
+++ b/templates/ppt/methods/pareto-chart-template.pptx
@@ -9,6 +9,12 @@
     <p:sldId id="257" r:id="rId8"/>
     <p:sldId id="258" r:id="rId9"/>
     <p:sldId id="259" r:id="rId10"/>
+    <p:sldId id="260" r:id="rId11"/>
+    <p:sldId id="261" r:id="rId12"/>
+    <p:sldId id="262" r:id="rId13"/>
+    <p:sldId id="263" r:id="rId14"/>
+    <p:sldId id="264" r:id="rId15"/>
+    <p:sldId id="265" r:id="rId16"/>
   </p:sldIdLst>
   <p:sldSz cx="12191999" cy="6858000" type="screen4x3"/>
   <p:notesSz cx="6858000" cy="9144000"/>
@@ -3411,7 +3417,7 @@
                   <a:srgbClr val="232D37"/>
                 </a:solidFill>
               </a:rPr>
-              <a:t>Identify the vital few defect categories from validated project data.</a:t>
+              <a:t>Purpose: identify the vital few categories from counted project data.</a:t>
             </a:r>
           </a:p>
         </p:txBody>
@@ -3669,6 +3675,505 @@
       <p:sp>
         <p:nvSpPr>
           <p:cNvPr id="9" name="TextBox 8"/>
+          <p:cNvSpPr txBox="1"/>
+          <p:nvPr/>
+        </p:nvSpPr>
+        <p:spPr>
+          <a:xfrm>
+            <a:off x="548640" y="6355080"/>
+            <a:ext cx="10881360" cy="228600"/>
+          </a:xfrm>
+          <a:prstGeom prst="rect">
+            <a:avLst/>
+          </a:prstGeom>
+          <a:noFill/>
+        </p:spPr>
+        <p:txBody>
+          <a:bodyPr wrap="square" lIns="73152" rIns="73152">
+            <a:spAutoFit/>
+          </a:bodyPr>
+          <a:lstStyle/>
+          <a:p>
+            <a:r>
+              <a:rPr sz="800" b="0">
+                <a:solidFill>
+                  <a:srgbClr val="697077"/>
+                </a:solidFill>
+              </a:rPr>
+              <a:t>pareto_chart_method_template | pareto_chart | Final data-dependent evidence belongs in the evidence package.</a:t>
+            </a:r>
+          </a:p>
+        </p:txBody>
+      </p:sp>
+    </p:spTree>
+  </p:cSld>
+  <p:clrMapOvr>
+    <a:masterClrMapping/>
+  </p:clrMapOvr>
+</p:sld>
+</file>
+
+<file path=ppt/slides/slide10.xml><?xml version="1.0" encoding="utf-8"?>
+<p:sld xmlns:a="http://schemas.openxmlformats.org/drawingml/2006/main" xmlns:p="http://schemas.openxmlformats.org/presentationml/2006/main" xmlns:r="http://schemas.openxmlformats.org/officeDocument/2006/relationships">
+  <p:cSld>
+    <p:spTree>
+      <p:nvGrpSpPr>
+        <p:cNvPr id="1" name=""/>
+        <p:cNvGrpSpPr/>
+        <p:nvPr/>
+      </p:nvGrpSpPr>
+      <p:grpSpPr/>
+      <p:sp>
+        <p:nvSpPr>
+          <p:cNvPr id="2" name="TextBox 1"/>
+          <p:cNvSpPr txBox="1"/>
+          <p:nvPr/>
+        </p:nvSpPr>
+        <p:spPr>
+          <a:xfrm>
+            <a:off x="502920" y="256032"/>
+            <a:ext cx="8321040" cy="420624"/>
+          </a:xfrm>
+          <a:prstGeom prst="rect">
+            <a:avLst/>
+          </a:prstGeom>
+          <a:noFill/>
+        </p:spPr>
+        <p:txBody>
+          <a:bodyPr wrap="square" lIns="73152" rIns="73152">
+            <a:spAutoFit/>
+          </a:bodyPr>
+          <a:lstStyle/>
+          <a:p>
+            <a:r>
+              <a:rPr sz="2400" b="1">
+                <a:solidFill>
+                  <a:srgbClr val="1B2733"/>
+                </a:solidFill>
+              </a:rPr>
+              <a:t>Blank copyable project slide</a:t>
+            </a:r>
+          </a:p>
+        </p:txBody>
+      </p:sp>
+      <p:sp>
+        <p:nvSpPr>
+          <p:cNvPr id="3" name="TextBox 2"/>
+          <p:cNvSpPr txBox="1"/>
+          <p:nvPr/>
+        </p:nvSpPr>
+        <p:spPr>
+          <a:xfrm>
+            <a:off x="521207" y="713232"/>
+            <a:ext cx="7772400" cy="237744"/>
+          </a:xfrm>
+          <a:prstGeom prst="rect">
+            <a:avLst/>
+          </a:prstGeom>
+          <a:noFill/>
+        </p:spPr>
+        <p:txBody>
+          <a:bodyPr wrap="square" lIns="73152" rIns="73152">
+            <a:spAutoFit/>
+          </a:bodyPr>
+          <a:lstStyle/>
+          <a:p>
+            <a:r>
+              <a:rPr sz="1100" b="0">
+                <a:solidFill>
+                  <a:srgbClr val="5A636C"/>
+                </a:solidFill>
+              </a:rPr>
+              <a:t>Pareto Chart</a:t>
+            </a:r>
+          </a:p>
+        </p:txBody>
+      </p:sp>
+      <p:sp>
+        <p:nvSpPr>
+          <p:cNvPr id="4" name="Rectangle 3"/>
+          <p:cNvSpPr/>
+          <p:nvPr/>
+        </p:nvSpPr>
+        <p:spPr>
+          <a:xfrm>
+            <a:off x="502920" y="941832"/>
+            <a:ext cx="11155680" cy="27432"/>
+          </a:xfrm>
+          <a:prstGeom prst="rect">
+            <a:avLst/>
+          </a:prstGeom>
+          <a:solidFill>
+            <a:srgbClr val="427E78"/>
+          </a:solidFill>
+          <a:ln>
+            <a:noFill/>
+          </a:ln>
+        </p:spPr>
+        <p:style>
+          <a:lnRef idx="1">
+            <a:schemeClr val="accent1"/>
+          </a:lnRef>
+          <a:fillRef idx="3">
+            <a:schemeClr val="accent1"/>
+          </a:fillRef>
+          <a:effectRef idx="2">
+            <a:schemeClr val="accent1"/>
+          </a:effectRef>
+          <a:fontRef idx="minor">
+            <a:schemeClr val="lt1"/>
+          </a:fontRef>
+        </p:style>
+        <p:txBody>
+          <a:bodyPr rtlCol="0" anchor="ctr"/>
+          <a:lstStyle/>
+          <a:p>
+            <a:pPr algn="ctr"/>
+          </a:p>
+        </p:txBody>
+      </p:sp>
+      <p:sp>
+        <p:nvSpPr>
+          <p:cNvPr id="5" name="Rounded Rectangle 4"/>
+          <p:cNvSpPr/>
+          <p:nvPr/>
+        </p:nvSpPr>
+        <p:spPr>
+          <a:xfrm>
+            <a:off x="640080" y="1051560"/>
+            <a:ext cx="4754880" cy="329184"/>
+          </a:xfrm>
+          <a:prstGeom prst="roundRect">
+            <a:avLst/>
+          </a:prstGeom>
+          <a:solidFill>
+            <a:srgbClr val="FFF2CC"/>
+          </a:solidFill>
+          <a:ln>
+            <a:solidFill>
+              <a:srgbClr val="D69F2E"/>
+            </a:solidFill>
+          </a:ln>
+        </p:spPr>
+        <p:style>
+          <a:lnRef idx="1">
+            <a:schemeClr val="accent1"/>
+          </a:lnRef>
+          <a:fillRef idx="3">
+            <a:schemeClr val="accent1"/>
+          </a:fillRef>
+          <a:effectRef idx="2">
+            <a:schemeClr val="accent1"/>
+          </a:effectRef>
+          <a:fontRef idx="minor">
+            <a:schemeClr val="lt1"/>
+          </a:fontRef>
+        </p:style>
+        <p:txBody>
+          <a:bodyPr rtlCol="0" anchor="ctr"/>
+          <a:lstStyle/>
+          <a:p>
+            <a:pPr algn="ctr"/>
+            <a:r>
+              <a:rPr b="1" sz="1100">
+                <a:solidFill>
+                  <a:srgbClr val="664B11"/>
+                </a:solidFill>
+              </a:rPr>
+              <a:t>Replace demo content with project evidence</a:t>
+            </a:r>
+          </a:p>
+        </p:txBody>
+      </p:sp>
+      <p:sp>
+        <p:nvSpPr>
+          <p:cNvPr id="6" name="Rounded Rectangle 5"/>
+          <p:cNvSpPr/>
+          <p:nvPr/>
+        </p:nvSpPr>
+        <p:spPr>
+          <a:xfrm>
+            <a:off x="640080" y="1691640"/>
+            <a:ext cx="5394960" cy="4206240"/>
+          </a:xfrm>
+          <a:prstGeom prst="roundRect">
+            <a:avLst/>
+          </a:prstGeom>
+          <a:solidFill>
+            <a:srgbClr val="F8F9F7"/>
+          </a:solidFill>
+          <a:ln>
+            <a:solidFill>
+              <a:srgbClr val="BEC4BF"/>
+            </a:solidFill>
+          </a:ln>
+        </p:spPr>
+        <p:style>
+          <a:lnRef idx="1">
+            <a:schemeClr val="accent1"/>
+          </a:lnRef>
+          <a:fillRef idx="3">
+            <a:schemeClr val="accent1"/>
+          </a:fillRef>
+          <a:effectRef idx="2">
+            <a:schemeClr val="accent1"/>
+          </a:effectRef>
+          <a:fontRef idx="minor">
+            <a:schemeClr val="lt1"/>
+          </a:fontRef>
+        </p:style>
+        <p:txBody>
+          <a:bodyPr rtlCol="0" anchor="t" lIns="164592" rIns="164592" tIns="128016"/>
+          <a:lstStyle/>
+          <a:p>
+            <a:pPr algn="ctr"/>
+            <a:r>
+              <a:rPr b="1" sz="1500">
+                <a:solidFill>
+                  <a:srgbClr val="1B2733"/>
+                </a:solidFill>
+              </a:rPr>
+              <a:t>Project slide checklist</a:t>
+            </a:r>
+          </a:p>
+          <a:p>
+            <a:pPr>
+              <a:defRPr sz="1100">
+                <a:solidFill>
+                  <a:srgbClr val="2D3741"/>
+                </a:solidFill>
+              </a:defRPr>
+            </a:pPr>
+            <a:r>
+              <a:t>Project title: [problem and period]</a:t>
+            </a:r>
+          </a:p>
+          <a:p>
+            <a:pPr>
+              <a:defRPr sz="1100">
+                <a:solidFill>
+                  <a:srgbClr val="2D3741"/>
+                </a:solidFill>
+              </a:defRPr>
+            </a:pPr>
+            <a:r>
+              <a:t>Chart area: replace demo data or insert generated chart.</a:t>
+            </a:r>
+          </a:p>
+          <a:p>
+            <a:pPr>
+              <a:defRPr sz="1100">
+                <a:solidFill>
+                  <a:srgbClr val="2D3741"/>
+                </a:solidFill>
+              </a:defRPr>
+            </a:pPr>
+            <a:r>
+              <a:t>Source: [system, sheet, or log owner]</a:t>
+            </a:r>
+          </a:p>
+          <a:p>
+            <a:pPr>
+              <a:defRPr sz="1100">
+                <a:solidFill>
+                  <a:srgbClr val="2D3741"/>
+                </a:solidFill>
+              </a:defRPr>
+            </a:pPr>
+            <a:r>
+              <a:t>Date range: [start to end]</a:t>
+            </a:r>
+          </a:p>
+          <a:p>
+            <a:pPr>
+              <a:defRPr sz="1100">
+                <a:solidFill>
+                  <a:srgbClr val="2D3741"/>
+                </a:solidFill>
+              </a:defRPr>
+            </a:pPr>
+            <a:r>
+              <a:t>Key finding: [largest contributor or top-three share]</a:t>
+            </a:r>
+          </a:p>
+          <a:p>
+            <a:pPr>
+              <a:defRPr sz="1100">
+                <a:solidFill>
+                  <a:srgbClr val="2D3741"/>
+                </a:solidFill>
+              </a:defRPr>
+            </a:pPr>
+            <a:r>
+              <a:t>Next action: [Fishbone, 5 Whys, or containment check]</a:t>
+            </a:r>
+          </a:p>
+          <a:p>
+            <a:pPr>
+              <a:defRPr sz="1100">
+                <a:solidFill>
+                  <a:srgbClr val="2D3741"/>
+                </a:solidFill>
+              </a:defRPr>
+            </a:pPr>
+            <a:r>
+              <a:t>Prepared by/date: [name and date]</a:t>
+            </a:r>
+          </a:p>
+        </p:txBody>
+      </p:sp>
+      <p:sp>
+        <p:nvSpPr>
+          <p:cNvPr id="7" name="Rounded Rectangle 6"/>
+          <p:cNvSpPr/>
+          <p:nvPr/>
+        </p:nvSpPr>
+        <p:spPr>
+          <a:xfrm>
+            <a:off x="6355080" y="1691640"/>
+            <a:ext cx="4892040" cy="4206240"/>
+          </a:xfrm>
+          <a:prstGeom prst="roundRect">
+            <a:avLst/>
+          </a:prstGeom>
+          <a:solidFill>
+            <a:srgbClr val="F8F9F7"/>
+          </a:solidFill>
+          <a:ln>
+            <a:solidFill>
+              <a:srgbClr val="BEC4BF"/>
+            </a:solidFill>
+          </a:ln>
+        </p:spPr>
+        <p:style>
+          <a:lnRef idx="1">
+            <a:schemeClr val="accent1"/>
+          </a:lnRef>
+          <a:fillRef idx="3">
+            <a:schemeClr val="accent1"/>
+          </a:fillRef>
+          <a:effectRef idx="2">
+            <a:schemeClr val="accent1"/>
+          </a:effectRef>
+          <a:fontRef idx="minor">
+            <a:schemeClr val="lt1"/>
+          </a:fontRef>
+        </p:style>
+        <p:txBody>
+          <a:bodyPr rtlCol="0" anchor="t" lIns="164592" rIns="164592" tIns="128016"/>
+          <a:lstStyle/>
+          <a:p>
+            <a:pPr algn="ctr"/>
+            <a:r>
+              <a:rPr b="1" sz="1500">
+                <a:solidFill>
+                  <a:srgbClr val="1B2733"/>
+                </a:solidFill>
+              </a:rPr>
+              <a:t>Reserved placeholders</a:t>
+            </a:r>
+          </a:p>
+          <a:p>
+            <a:pPr>
+              <a:defRPr sz="1100">
+                <a:solidFill>
+                  <a:srgbClr val="2D3741"/>
+                </a:solidFill>
+              </a:defRPr>
+            </a:pPr>
+            <a:r>
+              <a:t>{{method_name}}</a:t>
+            </a:r>
+          </a:p>
+          <a:p>
+            <a:pPr>
+              <a:defRPr sz="1100">
+                <a:solidFill>
+                  <a:srgbClr val="2D3741"/>
+                </a:solidFill>
+              </a:defRPr>
+            </a:pPr>
+            <a:r>
+              <a:t>{{qcc_stage}}</a:t>
+            </a:r>
+          </a:p>
+          <a:p>
+            <a:pPr>
+              <a:defRPr sz="1100">
+                <a:solidFill>
+                  <a:srgbClr val="2D3741"/>
+                </a:solidFill>
+              </a:defRPr>
+            </a:pPr>
+            <a:r>
+              <a:t>{{demo_label}}</a:t>
+            </a:r>
+          </a:p>
+          <a:p>
+            <a:pPr>
+              <a:defRPr sz="1100">
+                <a:solidFill>
+                  <a:srgbClr val="2D3741"/>
+                </a:solidFill>
+              </a:defRPr>
+            </a:pPr>
+            <a:r>
+              <a:t>{{chart_image}}</a:t>
+            </a:r>
+          </a:p>
+          <a:p>
+            <a:pPr>
+              <a:defRPr sz="1100">
+                <a:solidFill>
+                  <a:srgbClr val="2D3741"/>
+                </a:solidFill>
+              </a:defRPr>
+            </a:pPr>
+            <a:r>
+              <a:t>{{calculated_table}}</a:t>
+            </a:r>
+          </a:p>
+          <a:p>
+            <a:pPr>
+              <a:defRPr sz="1100">
+                <a:solidFill>
+                  <a:srgbClr val="2D3741"/>
+                </a:solidFill>
+              </a:defRPr>
+            </a:pPr>
+            <a:r>
+              <a:t>{{caption}}</a:t>
+            </a:r>
+          </a:p>
+          <a:p>
+            <a:pPr>
+              <a:defRPr sz="1100">
+                <a:solidFill>
+                  <a:srgbClr val="2D3741"/>
+                </a:solidFill>
+              </a:defRPr>
+            </a:pPr>
+            <a:r>
+              <a:t>{{data_context}}</a:t>
+            </a:r>
+          </a:p>
+          <a:p>
+            <a:pPr>
+              <a:defRPr sz="1100">
+                <a:solidFill>
+                  <a:srgbClr val="2D3741"/>
+                </a:solidFill>
+              </a:defRPr>
+            </a:pPr>
+            <a:r>
+              <a:t>{{warnings}}</a:t>
+            </a:r>
+          </a:p>
+        </p:txBody>
+      </p:sp>
+      <p:sp>
+        <p:nvSpPr>
+          <p:cNvPr id="8" name="TextBox 7"/>
           <p:cNvSpPr txBox="1"/>
           <p:nvPr/>
         </p:nvSpPr>
@@ -3745,7 +4250,7 @@
                   <a:srgbClr val="1B2733"/>
                 </a:solidFill>
               </a:rPr>
-              <a:t>DATA ENTRY - replace defect categories and counts only</a:t>
+              <a:t>DATA ENTRY - PowerPoint Edit Data - replace categories and counts only</a:t>
             </a:r>
           </a:p>
         </p:txBody>
@@ -4330,7 +4835,7 @@
                   <a:srgbClr val="1B2733"/>
                 </a:solidFill>
               </a:rPr>
-              <a:t>DEMO EXAMPLE - not project evidence</a:t>
+              <a:t>QCC stage fit and required inputs</a:t>
             </a:r>
           </a:p>
         </p:txBody>
@@ -4419,61 +4924,8 @@
         </p:nvSpPr>
         <p:spPr>
           <a:xfrm>
-            <a:off x="640080" y="1051560"/>
-            <a:ext cx="3840480" cy="329184"/>
-          </a:xfrm>
-          <a:prstGeom prst="roundRect">
-            <a:avLst/>
-          </a:prstGeom>
-          <a:solidFill>
-            <a:srgbClr val="FFF2CC"/>
-          </a:solidFill>
-          <a:ln>
-            <a:solidFill>
-              <a:srgbClr val="D69F2E"/>
-            </a:solidFill>
-          </a:ln>
-        </p:spPr>
-        <p:style>
-          <a:lnRef idx="1">
-            <a:schemeClr val="accent1"/>
-          </a:lnRef>
-          <a:fillRef idx="3">
-            <a:schemeClr val="accent1"/>
-          </a:fillRef>
-          <a:effectRef idx="2">
-            <a:schemeClr val="accent1"/>
-          </a:effectRef>
-          <a:fontRef idx="minor">
-            <a:schemeClr val="lt1"/>
-          </a:fontRef>
-        </p:style>
-        <p:txBody>
-          <a:bodyPr rtlCol="0" anchor="ctr"/>
-          <a:lstStyle/>
-          <a:p>
-            <a:pPr algn="ctr"/>
-            <a:r>
-              <a:rPr b="1" sz="1100">
-                <a:solidFill>
-                  <a:srgbClr val="664B11"/>
-                </a:solidFill>
-              </a:rPr>
-              <a:t>DEMO EXAMPLE - not project evidence</a:t>
-            </a:r>
-          </a:p>
-        </p:txBody>
-      </p:sp>
-      <p:sp>
-        <p:nvSpPr>
-          <p:cNvPr id="6" name="Rounded Rectangle 5"/>
-          <p:cNvSpPr/>
-          <p:nvPr/>
-        </p:nvSpPr>
-        <p:spPr>
-          <a:xfrm>
-            <a:off x="640080" y="1691640"/>
-            <a:ext cx="5394960" cy="4206240"/>
+            <a:off x="640080" y="1325880"/>
+            <a:ext cx="5212080" cy="4526280"/>
           </a:xfrm>
           <a:prstGeom prst="roundRect">
             <a:avLst/>
@@ -4512,93 +4964,57 @@
                   <a:srgbClr val="1B2733"/>
                 </a:solidFill>
               </a:rPr>
-              <a:t>Demo structure</a:t>
-            </a:r>
-          </a:p>
-          <a:p>
-            <a:pPr>
-              <a:defRPr sz="1100">
-                <a:solidFill>
-                  <a:srgbClr val="2D3741"/>
-                </a:solidFill>
-              </a:defRPr>
-            </a:pPr>
-            <a:r>
-              <a:t>Change data only: edit the chart data table or regenerate from Python.</a:t>
-            </a:r>
-          </a:p>
-          <a:p>
-            <a:pPr>
-              <a:defRPr sz="1100">
-                <a:solidFill>
-                  <a:srgbClr val="2D3741"/>
-                </a:solidFill>
-              </a:defRPr>
-            </a:pPr>
-            <a:r>
-              <a:t>Generated chart image slot: {{chart_image}}</a:t>
-            </a:r>
-          </a:p>
-          <a:p>
-            <a:pPr>
-              <a:defRPr sz="1100">
-                <a:solidFill>
-                  <a:srgbClr val="2D3741"/>
-                </a:solidFill>
-              </a:defRPr>
-            </a:pPr>
-            <a:r>
-              <a:t>Calculated table reference: {{calculated_table}}</a:t>
-            </a:r>
-          </a:p>
-          <a:p>
-            <a:pPr>
-              <a:defRPr sz="1100">
-                <a:solidFill>
-                  <a:srgbClr val="2D3741"/>
-                </a:solidFill>
-              </a:defRPr>
-            </a:pPr>
-            <a:r>
-              <a:t>Caption from evidence package: {{caption}}</a:t>
-            </a:r>
-          </a:p>
-          <a:p>
-            <a:pPr>
-              <a:defRPr sz="1100">
-                <a:solidFill>
-                  <a:srgbClr val="2D3741"/>
-                </a:solidFill>
-              </a:defRPr>
-            </a:pPr>
-            <a:r>
-              <a:t>Data context and filters: {{data_context}}</a:t>
-            </a:r>
-          </a:p>
-          <a:p>
-            <a:pPr>
-              <a:defRPr sz="1100">
-                <a:solidFill>
-                  <a:srgbClr val="2D3741"/>
-                </a:solidFill>
-              </a:defRPr>
-            </a:pPr>
-            <a:r>
-              <a:t>Warnings and cautions: {{warnings}}</a:t>
-            </a:r>
-          </a:p>
-        </p:txBody>
-      </p:sp>
-      <p:sp>
-        <p:nvSpPr>
-          <p:cNvPr id="7" name="Rounded Rectangle 6"/>
+              <a:t>QCC stage fit</a:t>
+            </a:r>
+          </a:p>
+          <a:p>
+            <a:pPr>
+              <a:defRPr sz="1100">
+                <a:solidFill>
+                  <a:srgbClr val="2D3741"/>
+                </a:solidFill>
+              </a:defRPr>
+            </a:pPr>
+            <a:r>
+              <a:t>Understand Current Condition: rank baseline categories.</a:t>
+            </a:r>
+          </a:p>
+          <a:p>
+            <a:pPr>
+              <a:defRPr sz="1100">
+                <a:solidFill>
+                  <a:srgbClr val="2D3741"/>
+                </a:solidFill>
+              </a:defRPr>
+            </a:pPr>
+            <a:r>
+              <a:t>Analyze Causes: choose where cause analysis starts.</a:t>
+            </a:r>
+          </a:p>
+          <a:p>
+            <a:pPr>
+              <a:defRPr sz="1100">
+                <a:solidFill>
+                  <a:srgbClr val="2D3741"/>
+                </a:solidFill>
+              </a:defRPr>
+            </a:pPr>
+            <a:r>
+              <a:t>Pareto shows concentration, not root cause.</a:t>
+            </a:r>
+          </a:p>
+        </p:txBody>
+      </p:sp>
+      <p:sp>
+        <p:nvSpPr>
+          <p:cNvPr id="6" name="Rounded Rectangle 5"/>
           <p:cNvSpPr/>
           <p:nvPr/>
         </p:nvSpPr>
         <p:spPr>
           <a:xfrm>
-            <a:off x="6355080" y="1691640"/>
-            <a:ext cx="4892040" cy="4206240"/>
+            <a:off x="6263640" y="1325880"/>
+            <a:ext cx="5212080" cy="4526280"/>
           </a:xfrm>
           <a:prstGeom prst="roundRect">
             <a:avLst/>
@@ -4637,110 +5053,62 @@
                   <a:srgbClr val="1B2733"/>
                 </a:solidFill>
               </a:rPr>
-              <a:t>Reserved placeholders</a:t>
-            </a:r>
-          </a:p>
-          <a:p>
-            <a:pPr>
-              <a:defRPr sz="1100">
-                <a:solidFill>
-                  <a:srgbClr val="2D3741"/>
-                </a:solidFill>
-              </a:defRPr>
-            </a:pPr>
-            <a:r>
-              <a:t>{{method_name}}</a:t>
-            </a:r>
-          </a:p>
-          <a:p>
-            <a:pPr>
-              <a:defRPr sz="1100">
-                <a:solidFill>
-                  <a:srgbClr val="2D3741"/>
-                </a:solidFill>
-              </a:defRPr>
-            </a:pPr>
-            <a:r>
-              <a:t>{{qcc_stage}}</a:t>
-            </a:r>
-          </a:p>
-          <a:p>
-            <a:pPr>
-              <a:defRPr sz="1100">
-                <a:solidFill>
-                  <a:srgbClr val="2D3741"/>
-                </a:solidFill>
-              </a:defRPr>
-            </a:pPr>
-            <a:r>
-              <a:t>{{demo_label}}</a:t>
-            </a:r>
-          </a:p>
-          <a:p>
-            <a:pPr>
-              <a:defRPr sz="1100">
-                <a:solidFill>
-                  <a:srgbClr val="2D3741"/>
-                </a:solidFill>
-              </a:defRPr>
-            </a:pPr>
-            <a:r>
-              <a:t>{{chart_image}}</a:t>
-            </a:r>
-          </a:p>
-          <a:p>
-            <a:pPr>
-              <a:defRPr sz="1100">
-                <a:solidFill>
-                  <a:srgbClr val="2D3741"/>
-                </a:solidFill>
-              </a:defRPr>
-            </a:pPr>
-            <a:r>
-              <a:t>{{calculated_table}}</a:t>
-            </a:r>
-          </a:p>
-          <a:p>
-            <a:pPr>
-              <a:defRPr sz="1100">
-                <a:solidFill>
-                  <a:srgbClr val="2D3741"/>
-                </a:solidFill>
-              </a:defRPr>
-            </a:pPr>
-            <a:r>
-              <a:t>{{caption}}</a:t>
-            </a:r>
-          </a:p>
-          <a:p>
-            <a:pPr>
-              <a:defRPr sz="1100">
-                <a:solidFill>
-                  <a:srgbClr val="2D3741"/>
-                </a:solidFill>
-              </a:defRPr>
-            </a:pPr>
-            <a:r>
-              <a:t>{{data_context}}</a:t>
-            </a:r>
-          </a:p>
-          <a:p>
-            <a:pPr>
-              <a:defRPr sz="1100">
-                <a:solidFill>
-                  <a:srgbClr val="2D3741"/>
-                </a:solidFill>
-              </a:defRPr>
-            </a:pPr>
-            <a:r>
-              <a:t>{{warnings}}</a:t>
-            </a:r>
-          </a:p>
-        </p:txBody>
-      </p:sp>
-      <p:sp>
-        <p:nvSpPr>
-          <p:cNvPr id="8" name="TextBox 7"/>
+              <a:t>Required inputs</a:t>
+            </a:r>
+          </a:p>
+          <a:p>
+            <a:pPr>
+              <a:defRPr sz="1100">
+                <a:solidFill>
+                  <a:srgbClr val="2D3741"/>
+                </a:solidFill>
+              </a:defRPr>
+            </a:pPr>
+            <a:r>
+              <a:t>Category and count.</a:t>
+            </a:r>
+          </a:p>
+          <a:p>
+            <a:pPr>
+              <a:defRPr sz="1100">
+                <a:solidFill>
+                  <a:srgbClr val="2D3741"/>
+                </a:solidFill>
+              </a:defRPr>
+            </a:pPr>
+            <a:r>
+              <a:t>Non-overlapping categories.</a:t>
+            </a:r>
+          </a:p>
+          <a:p>
+            <a:pPr>
+              <a:defRPr sz="1100">
+                <a:solidFill>
+                  <a:srgbClr val="2D3741"/>
+                </a:solidFill>
+              </a:defRPr>
+            </a:pPr>
+            <a:r>
+              <a:t>Consistent data period.</a:t>
+            </a:r>
+          </a:p>
+          <a:p>
+            <a:pPr>
+              <a:defRPr sz="1100">
+                <a:solidFill>
+                  <a:srgbClr val="2D3741"/>
+                </a:solidFill>
+              </a:defRPr>
+            </a:pPr>
+            <a:r>
+              <a:t>Source, date range, filters, and calculation notes.</a:t>
+            </a:r>
+          </a:p>
+        </p:txBody>
+      </p:sp>
+      <p:sp>
+        <p:nvSpPr>
+          <p:cNvPr id="7" name="TextBox 6"/>
           <p:cNvSpPr txBox="1"/>
           <p:nvPr/>
         </p:nvSpPr>
@@ -4817,7 +5185,7 @@
                   <a:srgbClr val="1B2733"/>
                 </a:solidFill>
               </a:rPr>
-              <a:t>Project Pareto Evidence</a:t>
+              <a:t>When to use and when not to use</a:t>
             </a:r>
           </a:p>
         </p:txBody>
@@ -4906,8 +5274,1830 @@
         </p:nvSpPr>
         <p:spPr>
           <a:xfrm>
+            <a:off x="640080" y="1325880"/>
+            <a:ext cx="5212080" cy="4526280"/>
+          </a:xfrm>
+          <a:prstGeom prst="roundRect">
+            <a:avLst/>
+          </a:prstGeom>
+          <a:solidFill>
+            <a:srgbClr val="F8F9F7"/>
+          </a:solidFill>
+          <a:ln>
+            <a:solidFill>
+              <a:srgbClr val="BEC4BF"/>
+            </a:solidFill>
+          </a:ln>
+        </p:spPr>
+        <p:style>
+          <a:lnRef idx="1">
+            <a:schemeClr val="accent1"/>
+          </a:lnRef>
+          <a:fillRef idx="3">
+            <a:schemeClr val="accent1"/>
+          </a:fillRef>
+          <a:effectRef idx="2">
+            <a:schemeClr val="accent1"/>
+          </a:effectRef>
+          <a:fontRef idx="minor">
+            <a:schemeClr val="lt1"/>
+          </a:fontRef>
+        </p:style>
+        <p:txBody>
+          <a:bodyPr rtlCol="0" anchor="t" lIns="164592" rIns="164592" tIns="128016"/>
+          <a:lstStyle/>
+          <a:p>
+            <a:pPr algn="ctr"/>
+            <a:r>
+              <a:rPr b="1" sz="1500">
+                <a:solidFill>
+                  <a:srgbClr val="1B2733"/>
+                </a:solidFill>
+              </a:rPr>
+              <a:t>When to use</a:t>
+            </a:r>
+          </a:p>
+          <a:p>
+            <a:pPr>
+              <a:defRPr sz="1100">
+                <a:solidFill>
+                  <a:srgbClr val="2D3741"/>
+                </a:solidFill>
+              </a:defRPr>
+            </a:pPr>
+            <a:r>
+              <a:t>Defect, complaint, delay, or event categories can be counted.</a:t>
+            </a:r>
+          </a:p>
+          <a:p>
+            <a:pPr>
+              <a:defRPr sz="1100">
+                <a:solidFill>
+                  <a:srgbClr val="2D3741"/>
+                </a:solidFill>
+              </a:defRPr>
+            </a:pPr>
+            <a:r>
+              <a:t>The team needs a focus decision before deeper analysis.</a:t>
+            </a:r>
+          </a:p>
+          <a:p>
+            <a:pPr>
+              <a:defRPr sz="1100">
+                <a:solidFill>
+                  <a:srgbClr val="2D3741"/>
+                </a:solidFill>
+              </a:defRPr>
+            </a:pPr>
+            <a:r>
+              <a:t>Small category-count data can be edited in PowerPoint.</a:t>
+            </a:r>
+          </a:p>
+        </p:txBody>
+      </p:sp>
+      <p:sp>
+        <p:nvSpPr>
+          <p:cNvPr id="6" name="Rounded Rectangle 5"/>
+          <p:cNvSpPr/>
+          <p:nvPr/>
+        </p:nvSpPr>
+        <p:spPr>
+          <a:xfrm>
+            <a:off x="6263640" y="1325880"/>
+            <a:ext cx="5212080" cy="4526280"/>
+          </a:xfrm>
+          <a:prstGeom prst="roundRect">
+            <a:avLst/>
+          </a:prstGeom>
+          <a:solidFill>
+            <a:srgbClr val="F8F9F7"/>
+          </a:solidFill>
+          <a:ln>
+            <a:solidFill>
+              <a:srgbClr val="BEC4BF"/>
+            </a:solidFill>
+          </a:ln>
+        </p:spPr>
+        <p:style>
+          <a:lnRef idx="1">
+            <a:schemeClr val="accent1"/>
+          </a:lnRef>
+          <a:fillRef idx="3">
+            <a:schemeClr val="accent1"/>
+          </a:fillRef>
+          <a:effectRef idx="2">
+            <a:schemeClr val="accent1"/>
+          </a:effectRef>
+          <a:fontRef idx="minor">
+            <a:schemeClr val="lt1"/>
+          </a:fontRef>
+        </p:style>
+        <p:txBody>
+          <a:bodyPr rtlCol="0" anchor="t" lIns="164592" rIns="164592" tIns="128016"/>
+          <a:lstStyle/>
+          <a:p>
+            <a:pPr algn="ctr"/>
+            <a:r>
+              <a:rPr b="1" sz="1500">
+                <a:solidFill>
+                  <a:srgbClr val="1B2733"/>
+                </a:solidFill>
+              </a:rPr>
+              <a:t>When not to use</a:t>
+            </a:r>
+          </a:p>
+          <a:p>
+            <a:pPr>
+              <a:defRPr sz="1100">
+                <a:solidFill>
+                  <a:srgbClr val="2D3741"/>
+                </a:solidFill>
+              </a:defRPr>
+            </a:pPr>
+            <a:r>
+              <a:t>Categories overlap or were changed after seeing the answer.</a:t>
+            </a:r>
+          </a:p>
+          <a:p>
+            <a:pPr>
+              <a:defRPr sz="1100">
+                <a:solidFill>
+                  <a:srgbClr val="2D3741"/>
+                </a:solidFill>
+              </a:defRPr>
+            </a:pPr>
+            <a:r>
+              <a:t>Data periods are mixed.</a:t>
+            </a:r>
+          </a:p>
+          <a:p>
+            <a:pPr>
+              <a:defRPr sz="1100">
+                <a:solidFill>
+                  <a:srgbClr val="2D3741"/>
+                </a:solidFill>
+              </a:defRPr>
+            </a:pPr>
+            <a:r>
+              <a:t>The team needs proof of root cause.</a:t>
+            </a:r>
+          </a:p>
+          <a:p>
+            <a:pPr>
+              <a:defRPr sz="1100">
+                <a:solidFill>
+                  <a:srgbClr val="2D3741"/>
+                </a:solidFill>
+              </a:defRPr>
+            </a:pPr>
+            <a:r>
+              <a:t>The conclusion is high-rigor without reproducible evidence.</a:t>
+            </a:r>
+          </a:p>
+        </p:txBody>
+      </p:sp>
+      <p:sp>
+        <p:nvSpPr>
+          <p:cNvPr id="7" name="TextBox 6"/>
+          <p:cNvSpPr txBox="1"/>
+          <p:nvPr/>
+        </p:nvSpPr>
+        <p:spPr>
+          <a:xfrm>
+            <a:off x="548640" y="6355080"/>
+            <a:ext cx="10881360" cy="228600"/>
+          </a:xfrm>
+          <a:prstGeom prst="rect">
+            <a:avLst/>
+          </a:prstGeom>
+          <a:noFill/>
+        </p:spPr>
+        <p:txBody>
+          <a:bodyPr wrap="square" lIns="73152" rIns="73152">
+            <a:spAutoFit/>
+          </a:bodyPr>
+          <a:lstStyle/>
+          <a:p>
+            <a:r>
+              <a:rPr sz="800" b="0">
+                <a:solidFill>
+                  <a:srgbClr val="697077"/>
+                </a:solidFill>
+              </a:rPr>
+              <a:t>pareto_chart_method_template | pareto_chart | Final data-dependent evidence belongs in the evidence package.</a:t>
+            </a:r>
+          </a:p>
+        </p:txBody>
+      </p:sp>
+    </p:spTree>
+  </p:cSld>
+  <p:clrMapOvr>
+    <a:masterClrMapping/>
+  </p:clrMapOvr>
+</p:sld>
+</file>
+
+<file path=ppt/slides/slide5.xml><?xml version="1.0" encoding="utf-8"?>
+<p:sld xmlns:a="http://schemas.openxmlformats.org/drawingml/2006/main" xmlns:p="http://schemas.openxmlformats.org/presentationml/2006/main" xmlns:r="http://schemas.openxmlformats.org/officeDocument/2006/relationships">
+  <p:cSld>
+    <p:spTree>
+      <p:nvGrpSpPr>
+        <p:cNvPr id="1" name=""/>
+        <p:cNvGrpSpPr/>
+        <p:nvPr/>
+      </p:nvGrpSpPr>
+      <p:grpSpPr/>
+      <p:sp>
+        <p:nvSpPr>
+          <p:cNvPr id="2" name="TextBox 1"/>
+          <p:cNvSpPr txBox="1"/>
+          <p:nvPr/>
+        </p:nvSpPr>
+        <p:spPr>
+          <a:xfrm>
+            <a:off x="502920" y="256032"/>
+            <a:ext cx="8321040" cy="420624"/>
+          </a:xfrm>
+          <a:prstGeom prst="rect">
+            <a:avLst/>
+          </a:prstGeom>
+          <a:noFill/>
+        </p:spPr>
+        <p:txBody>
+          <a:bodyPr wrap="square" lIns="73152" rIns="73152">
+            <a:spAutoFit/>
+          </a:bodyPr>
+          <a:lstStyle/>
+          <a:p>
+            <a:r>
+              <a:rPr sz="2400" b="1">
+                <a:solidFill>
+                  <a:srgbClr val="1B2733"/>
+                </a:solidFill>
+              </a:rPr>
+              <a:t>PowerPoint edit instructions</a:t>
+            </a:r>
+          </a:p>
+        </p:txBody>
+      </p:sp>
+      <p:sp>
+        <p:nvSpPr>
+          <p:cNvPr id="3" name="TextBox 2"/>
+          <p:cNvSpPr txBox="1"/>
+          <p:nvPr/>
+        </p:nvSpPr>
+        <p:spPr>
+          <a:xfrm>
+            <a:off x="521207" y="713232"/>
+            <a:ext cx="7772400" cy="237744"/>
+          </a:xfrm>
+          <a:prstGeom prst="rect">
+            <a:avLst/>
+          </a:prstGeom>
+          <a:noFill/>
+        </p:spPr>
+        <p:txBody>
+          <a:bodyPr wrap="square" lIns="73152" rIns="73152">
+            <a:spAutoFit/>
+          </a:bodyPr>
+          <a:lstStyle/>
+          <a:p>
+            <a:r>
+              <a:rPr sz="1100" b="0">
+                <a:solidFill>
+                  <a:srgbClr val="5A636C"/>
+                </a:solidFill>
+              </a:rPr>
+              <a:t>Pareto Chart</a:t>
+            </a:r>
+          </a:p>
+        </p:txBody>
+      </p:sp>
+      <p:sp>
+        <p:nvSpPr>
+          <p:cNvPr id="4" name="Rectangle 3"/>
+          <p:cNvSpPr/>
+          <p:nvPr/>
+        </p:nvSpPr>
+        <p:spPr>
+          <a:xfrm>
+            <a:off x="502920" y="941832"/>
+            <a:ext cx="11155680" cy="27432"/>
+          </a:xfrm>
+          <a:prstGeom prst="rect">
+            <a:avLst/>
+          </a:prstGeom>
+          <a:solidFill>
+            <a:srgbClr val="427E78"/>
+          </a:solidFill>
+          <a:ln>
+            <a:noFill/>
+          </a:ln>
+        </p:spPr>
+        <p:style>
+          <a:lnRef idx="1">
+            <a:schemeClr val="accent1"/>
+          </a:lnRef>
+          <a:fillRef idx="3">
+            <a:schemeClr val="accent1"/>
+          </a:fillRef>
+          <a:effectRef idx="2">
+            <a:schemeClr val="accent1"/>
+          </a:effectRef>
+          <a:fontRef idx="minor">
+            <a:schemeClr val="lt1"/>
+          </a:fontRef>
+        </p:style>
+        <p:txBody>
+          <a:bodyPr rtlCol="0" anchor="ctr"/>
+          <a:lstStyle/>
+          <a:p>
+            <a:pPr algn="ctr"/>
+          </a:p>
+        </p:txBody>
+      </p:sp>
+      <p:sp>
+        <p:nvSpPr>
+          <p:cNvPr id="5" name="Rounded Rectangle 4"/>
+          <p:cNvSpPr/>
+          <p:nvPr/>
+        </p:nvSpPr>
+        <p:spPr>
+          <a:xfrm>
+            <a:off x="640080" y="1325880"/>
+            <a:ext cx="5212080" cy="4526280"/>
+          </a:xfrm>
+          <a:prstGeom prst="roundRect">
+            <a:avLst/>
+          </a:prstGeom>
+          <a:solidFill>
+            <a:srgbClr val="F8F9F7"/>
+          </a:solidFill>
+          <a:ln>
+            <a:solidFill>
+              <a:srgbClr val="BEC4BF"/>
+            </a:solidFill>
+          </a:ln>
+        </p:spPr>
+        <p:style>
+          <a:lnRef idx="1">
+            <a:schemeClr val="accent1"/>
+          </a:lnRef>
+          <a:fillRef idx="3">
+            <a:schemeClr val="accent1"/>
+          </a:fillRef>
+          <a:effectRef idx="2">
+            <a:schemeClr val="accent1"/>
+          </a:effectRef>
+          <a:fontRef idx="minor">
+            <a:schemeClr val="lt1"/>
+          </a:fontRef>
+        </p:style>
+        <p:txBody>
+          <a:bodyPr rtlCol="0" anchor="t" lIns="164592" rIns="164592" tIns="128016"/>
+          <a:lstStyle/>
+          <a:p>
+            <a:pPr algn="ctr"/>
+            <a:r>
+              <a:rPr b="1" sz="1500">
+                <a:solidFill>
+                  <a:srgbClr val="1B2733"/>
+                </a:solidFill>
+              </a:rPr>
+              <a:t>Edit chart data</a:t>
+            </a:r>
+          </a:p>
+          <a:p>
+            <a:pPr>
+              <a:defRPr sz="1100">
+                <a:solidFill>
+                  <a:srgbClr val="2D3741"/>
+                </a:solidFill>
+              </a:defRPr>
+            </a:pPr>
+            <a:r>
+              <a:t>Right-click the chart and choose Edit Data.</a:t>
+            </a:r>
+          </a:p>
+          <a:p>
+            <a:pPr>
+              <a:defRPr sz="1100">
+                <a:solidFill>
+                  <a:srgbClr val="2D3741"/>
+                </a:solidFill>
+              </a:defRPr>
+            </a:pPr>
+            <a:r>
+              <a:t>Replace demo categories and counts.</a:t>
+            </a:r>
+          </a:p>
+          <a:p>
+            <a:pPr>
+              <a:defRPr sz="1100">
+                <a:solidFill>
+                  <a:srgbClr val="2D3741"/>
+                </a:solidFill>
+              </a:defRPr>
+            </a:pPr>
+            <a:r>
+              <a:t>Sort counts descending.</a:t>
+            </a:r>
+          </a:p>
+          <a:p>
+            <a:pPr>
+              <a:defRPr sz="1100">
+                <a:solidFill>
+                  <a:srgbClr val="2D3741"/>
+                </a:solidFill>
+              </a:defRPr>
+            </a:pPr>
+            <a:r>
+              <a:t>Verify formula cells were not overwritten.</a:t>
+            </a:r>
+          </a:p>
+        </p:txBody>
+      </p:sp>
+      <p:sp>
+        <p:nvSpPr>
+          <p:cNvPr id="6" name="Rounded Rectangle 5"/>
+          <p:cNvSpPr/>
+          <p:nvPr/>
+        </p:nvSpPr>
+        <p:spPr>
+          <a:xfrm>
+            <a:off x="6263640" y="1325880"/>
+            <a:ext cx="5212080" cy="4526280"/>
+          </a:xfrm>
+          <a:prstGeom prst="roundRect">
+            <a:avLst/>
+          </a:prstGeom>
+          <a:solidFill>
+            <a:srgbClr val="F8F9F7"/>
+          </a:solidFill>
+          <a:ln>
+            <a:solidFill>
+              <a:srgbClr val="BEC4BF"/>
+            </a:solidFill>
+          </a:ln>
+        </p:spPr>
+        <p:style>
+          <a:lnRef idx="1">
+            <a:schemeClr val="accent1"/>
+          </a:lnRef>
+          <a:fillRef idx="3">
+            <a:schemeClr val="accent1"/>
+          </a:fillRef>
+          <a:effectRef idx="2">
+            <a:schemeClr val="accent1"/>
+          </a:effectRef>
+          <a:fontRef idx="minor">
+            <a:schemeClr val="lt1"/>
+          </a:fontRef>
+        </p:style>
+        <p:txBody>
+          <a:bodyPr rtlCol="0" anchor="t" lIns="164592" rIns="164592" tIns="128016"/>
+          <a:lstStyle/>
+          <a:p>
+            <a:pPr algn="ctr"/>
+            <a:r>
+              <a:rPr b="1" sz="1500">
+                <a:solidFill>
+                  <a:srgbClr val="1B2733"/>
+                </a:solidFill>
+              </a:rPr>
+              <a:t>Review before use</a:t>
+            </a:r>
+          </a:p>
+          <a:p>
+            <a:pPr>
+              <a:defRPr sz="1100">
+                <a:solidFill>
+                  <a:srgbClr val="2D3741"/>
+                </a:solidFill>
+              </a:defRPr>
+            </a:pPr>
+            <a:r>
+              <a:t>Keep source and date range visible.</a:t>
+            </a:r>
+          </a:p>
+          <a:p>
+            <a:pPr>
+              <a:defRPr sz="1100">
+                <a:solidFill>
+                  <a:srgbClr val="2D3741"/>
+                </a:solidFill>
+              </a:defRPr>
+            </a:pPr>
+            <a:r>
+              <a:t>Do not present demo data as project evidence.</a:t>
+            </a:r>
+          </a:p>
+          <a:p>
+            <a:pPr>
+              <a:defRPr sz="1100">
+                <a:solidFill>
+                  <a:srgbClr val="2D3741"/>
+                </a:solidFill>
+              </a:defRPr>
+            </a:pPr>
+            <a:r>
+              <a:t>Check cumulative values if used.</a:t>
+            </a:r>
+          </a:p>
+          <a:p>
+            <a:pPr>
+              <a:defRPr sz="1100">
+                <a:solidFill>
+                  <a:srgbClr val="2D3741"/>
+                </a:solidFill>
+              </a:defRPr>
+            </a:pPr>
+            <a:r>
+              <a:t>Write Key finding and Next action.</a:t>
+            </a:r>
+          </a:p>
+        </p:txBody>
+      </p:sp>
+      <p:sp>
+        <p:nvSpPr>
+          <p:cNvPr id="7" name="TextBox 6"/>
+          <p:cNvSpPr txBox="1"/>
+          <p:nvPr/>
+        </p:nvSpPr>
+        <p:spPr>
+          <a:xfrm>
+            <a:off x="548640" y="6355080"/>
+            <a:ext cx="10881360" cy="228600"/>
+          </a:xfrm>
+          <a:prstGeom prst="rect">
+            <a:avLst/>
+          </a:prstGeom>
+          <a:noFill/>
+        </p:spPr>
+        <p:txBody>
+          <a:bodyPr wrap="square" lIns="73152" rIns="73152">
+            <a:spAutoFit/>
+          </a:bodyPr>
+          <a:lstStyle/>
+          <a:p>
+            <a:r>
+              <a:rPr sz="800" b="0">
+                <a:solidFill>
+                  <a:srgbClr val="697077"/>
+                </a:solidFill>
+              </a:rPr>
+              <a:t>pareto_chart_method_template | pareto_chart | Final data-dependent evidence belongs in the evidence package.</a:t>
+            </a:r>
+          </a:p>
+        </p:txBody>
+      </p:sp>
+    </p:spTree>
+  </p:cSld>
+  <p:clrMapOvr>
+    <a:masterClrMapping/>
+  </p:clrMapOvr>
+</p:sld>
+</file>
+
+<file path=ppt/slides/slide6.xml><?xml version="1.0" encoding="utf-8"?>
+<p:sld xmlns:a="http://schemas.openxmlformats.org/drawingml/2006/main" xmlns:p="http://schemas.openxmlformats.org/presentationml/2006/main" xmlns:r="http://schemas.openxmlformats.org/officeDocument/2006/relationships">
+  <p:cSld>
+    <p:spTree>
+      <p:nvGrpSpPr>
+        <p:cNvPr id="1" name=""/>
+        <p:cNvGrpSpPr/>
+        <p:nvPr/>
+      </p:nvGrpSpPr>
+      <p:grpSpPr/>
+      <p:sp>
+        <p:nvSpPr>
+          <p:cNvPr id="2" name="TextBox 1"/>
+          <p:cNvSpPr txBox="1"/>
+          <p:nvPr/>
+        </p:nvSpPr>
+        <p:spPr>
+          <a:xfrm>
+            <a:off x="502920" y="256032"/>
+            <a:ext cx="8321040" cy="420624"/>
+          </a:xfrm>
+          <a:prstGeom prst="rect">
+            <a:avLst/>
+          </a:prstGeom>
+          <a:noFill/>
+        </p:spPr>
+        <p:txBody>
+          <a:bodyPr wrap="square" lIns="73152" rIns="73152">
+            <a:spAutoFit/>
+          </a:bodyPr>
+          <a:lstStyle/>
+          <a:p>
+            <a:r>
+              <a:rPr sz="2400" b="1">
+                <a:solidFill>
+                  <a:srgbClr val="1B2733"/>
+                </a:solidFill>
+              </a:rPr>
+              <a:t>Interpretation patterns and common mistakes</a:t>
+            </a:r>
+          </a:p>
+        </p:txBody>
+      </p:sp>
+      <p:sp>
+        <p:nvSpPr>
+          <p:cNvPr id="3" name="TextBox 2"/>
+          <p:cNvSpPr txBox="1"/>
+          <p:nvPr/>
+        </p:nvSpPr>
+        <p:spPr>
+          <a:xfrm>
+            <a:off x="521207" y="713232"/>
+            <a:ext cx="7772400" cy="237744"/>
+          </a:xfrm>
+          <a:prstGeom prst="rect">
+            <a:avLst/>
+          </a:prstGeom>
+          <a:noFill/>
+        </p:spPr>
+        <p:txBody>
+          <a:bodyPr wrap="square" lIns="73152" rIns="73152">
+            <a:spAutoFit/>
+          </a:bodyPr>
+          <a:lstStyle/>
+          <a:p>
+            <a:r>
+              <a:rPr sz="1100" b="0">
+                <a:solidFill>
+                  <a:srgbClr val="5A636C"/>
+                </a:solidFill>
+              </a:rPr>
+              <a:t>Pareto Chart</a:t>
+            </a:r>
+          </a:p>
+        </p:txBody>
+      </p:sp>
+      <p:sp>
+        <p:nvSpPr>
+          <p:cNvPr id="4" name="Rectangle 3"/>
+          <p:cNvSpPr/>
+          <p:nvPr/>
+        </p:nvSpPr>
+        <p:spPr>
+          <a:xfrm>
+            <a:off x="502920" y="941832"/>
+            <a:ext cx="11155680" cy="27432"/>
+          </a:xfrm>
+          <a:prstGeom prst="rect">
+            <a:avLst/>
+          </a:prstGeom>
+          <a:solidFill>
+            <a:srgbClr val="427E78"/>
+          </a:solidFill>
+          <a:ln>
+            <a:noFill/>
+          </a:ln>
+        </p:spPr>
+        <p:style>
+          <a:lnRef idx="1">
+            <a:schemeClr val="accent1"/>
+          </a:lnRef>
+          <a:fillRef idx="3">
+            <a:schemeClr val="accent1"/>
+          </a:fillRef>
+          <a:effectRef idx="2">
+            <a:schemeClr val="accent1"/>
+          </a:effectRef>
+          <a:fontRef idx="minor">
+            <a:schemeClr val="lt1"/>
+          </a:fontRef>
+        </p:style>
+        <p:txBody>
+          <a:bodyPr rtlCol="0" anchor="ctr"/>
+          <a:lstStyle/>
+          <a:p>
+            <a:pPr algn="ctr"/>
+          </a:p>
+        </p:txBody>
+      </p:sp>
+      <p:sp>
+        <p:nvSpPr>
+          <p:cNvPr id="5" name="Rounded Rectangle 4"/>
+          <p:cNvSpPr/>
+          <p:nvPr/>
+        </p:nvSpPr>
+        <p:spPr>
+          <a:xfrm>
+            <a:off x="640080" y="1325880"/>
+            <a:ext cx="5212080" cy="4526280"/>
+          </a:xfrm>
+          <a:prstGeom prst="roundRect">
+            <a:avLst/>
+          </a:prstGeom>
+          <a:solidFill>
+            <a:srgbClr val="F8F9F7"/>
+          </a:solidFill>
+          <a:ln>
+            <a:solidFill>
+              <a:srgbClr val="BEC4BF"/>
+            </a:solidFill>
+          </a:ln>
+        </p:spPr>
+        <p:style>
+          <a:lnRef idx="1">
+            <a:schemeClr val="accent1"/>
+          </a:lnRef>
+          <a:fillRef idx="3">
+            <a:schemeClr val="accent1"/>
+          </a:fillRef>
+          <a:effectRef idx="2">
+            <a:schemeClr val="accent1"/>
+          </a:effectRef>
+          <a:fontRef idx="minor">
+            <a:schemeClr val="lt1"/>
+          </a:fontRef>
+        </p:style>
+        <p:txBody>
+          <a:bodyPr rtlCol="0" anchor="t" lIns="164592" rIns="164592" tIns="128016"/>
+          <a:lstStyle/>
+          <a:p>
+            <a:pPr algn="ctr"/>
+            <a:r>
+              <a:rPr b="1" sz="1500">
+                <a:solidFill>
+                  <a:srgbClr val="1B2733"/>
+                </a:solidFill>
+              </a:rPr>
+              <a:t>Interpretation patterns</a:t>
+            </a:r>
+          </a:p>
+          <a:p>
+            <a:pPr>
+              <a:defRPr sz="1100">
+                <a:solidFill>
+                  <a:srgbClr val="2D3741"/>
+                </a:solidFill>
+              </a:defRPr>
+            </a:pPr>
+            <a:r>
+              <a:t>Largest contributor: name the top category and count.</a:t>
+            </a:r>
+          </a:p>
+          <a:p>
+            <a:pPr>
+              <a:defRPr sz="1100">
+                <a:solidFill>
+                  <a:srgbClr val="2D3741"/>
+                </a:solidFill>
+              </a:defRPr>
+            </a:pPr>
+            <a:r>
+              <a:t>Top-three share: state combined contribution.</a:t>
+            </a:r>
+          </a:p>
+          <a:p>
+            <a:pPr>
+              <a:defRPr sz="1100">
+                <a:solidFill>
+                  <a:srgbClr val="2D3741"/>
+                </a:solidFill>
+              </a:defRPr>
+            </a:pPr>
+            <a:r>
+              <a:t>Focus decision: name the next method.</a:t>
+            </a:r>
+          </a:p>
+          <a:p>
+            <a:pPr>
+              <a:defRPr sz="1100">
+                <a:solidFill>
+                  <a:srgbClr val="2D3741"/>
+                </a:solidFill>
+              </a:defRPr>
+            </a:pPr>
+            <a:r>
+              <a:t>Caution: Pareto does not prove root cause.</a:t>
+            </a:r>
+          </a:p>
+        </p:txBody>
+      </p:sp>
+      <p:sp>
+        <p:nvSpPr>
+          <p:cNvPr id="6" name="Rounded Rectangle 5"/>
+          <p:cNvSpPr/>
+          <p:nvPr/>
+        </p:nvSpPr>
+        <p:spPr>
+          <a:xfrm>
+            <a:off x="6263640" y="1325880"/>
+            <a:ext cx="5212080" cy="4526280"/>
+          </a:xfrm>
+          <a:prstGeom prst="roundRect">
+            <a:avLst/>
+          </a:prstGeom>
+          <a:solidFill>
+            <a:srgbClr val="F8F9F7"/>
+          </a:solidFill>
+          <a:ln>
+            <a:solidFill>
+              <a:srgbClr val="BEC4BF"/>
+            </a:solidFill>
+          </a:ln>
+        </p:spPr>
+        <p:style>
+          <a:lnRef idx="1">
+            <a:schemeClr val="accent1"/>
+          </a:lnRef>
+          <a:fillRef idx="3">
+            <a:schemeClr val="accent1"/>
+          </a:fillRef>
+          <a:effectRef idx="2">
+            <a:schemeClr val="accent1"/>
+          </a:effectRef>
+          <a:fontRef idx="minor">
+            <a:schemeClr val="lt1"/>
+          </a:fontRef>
+        </p:style>
+        <p:txBody>
+          <a:bodyPr rtlCol="0" anchor="t" lIns="164592" rIns="164592" tIns="128016"/>
+          <a:lstStyle/>
+          <a:p>
+            <a:pPr algn="ctr"/>
+            <a:r>
+              <a:rPr b="1" sz="1500">
+                <a:solidFill>
+                  <a:srgbClr val="1B2733"/>
+                </a:solidFill>
+              </a:rPr>
+              <a:t>Common mistakes</a:t>
+            </a:r>
+          </a:p>
+          <a:p>
+            <a:pPr>
+              <a:defRPr sz="1100">
+                <a:solidFill>
+                  <a:srgbClr val="2D3741"/>
+                </a:solidFill>
+              </a:defRPr>
+            </a:pPr>
+            <a:r>
+              <a:t>Unsorted bars.</a:t>
+            </a:r>
+          </a:p>
+          <a:p>
+            <a:pPr>
+              <a:defRPr sz="1100">
+                <a:solidFill>
+                  <a:srgbClr val="2D3741"/>
+                </a:solidFill>
+              </a:defRPr>
+            </a:pPr>
+            <a:r>
+              <a:t>Overlapping categories.</a:t>
+            </a:r>
+          </a:p>
+          <a:p>
+            <a:pPr>
+              <a:defRPr sz="1100">
+                <a:solidFill>
+                  <a:srgbClr val="2D3741"/>
+                </a:solidFill>
+              </a:defRPr>
+            </a:pPr>
+            <a:r>
+              <a:t>Mixed time periods.</a:t>
+            </a:r>
+          </a:p>
+          <a:p>
+            <a:pPr>
+              <a:defRPr sz="1100">
+                <a:solidFill>
+                  <a:srgbClr val="2D3741"/>
+                </a:solidFill>
+              </a:defRPr>
+            </a:pPr>
+            <a:r>
+              <a:t>Missing source or date range.</a:t>
+            </a:r>
+          </a:p>
+          <a:p>
+            <a:pPr>
+              <a:defRPr sz="1100">
+                <a:solidFill>
+                  <a:srgbClr val="2D3741"/>
+                </a:solidFill>
+              </a:defRPr>
+            </a:pPr>
+            <a:r>
+              <a:t>Demo data used as project evidence.</a:t>
+            </a:r>
+          </a:p>
+        </p:txBody>
+      </p:sp>
+      <p:sp>
+        <p:nvSpPr>
+          <p:cNvPr id="7" name="TextBox 6"/>
+          <p:cNvSpPr txBox="1"/>
+          <p:nvPr/>
+        </p:nvSpPr>
+        <p:spPr>
+          <a:xfrm>
+            <a:off x="548640" y="6355080"/>
+            <a:ext cx="10881360" cy="228600"/>
+          </a:xfrm>
+          <a:prstGeom prst="rect">
+            <a:avLst/>
+          </a:prstGeom>
+          <a:noFill/>
+        </p:spPr>
+        <p:txBody>
+          <a:bodyPr wrap="square" lIns="73152" rIns="73152">
+            <a:spAutoFit/>
+          </a:bodyPr>
+          <a:lstStyle/>
+          <a:p>
+            <a:r>
+              <a:rPr sz="800" b="0">
+                <a:solidFill>
+                  <a:srgbClr val="697077"/>
+                </a:solidFill>
+              </a:rPr>
+              <a:t>pareto_chart_method_template | pareto_chart | Final data-dependent evidence belongs in the evidence package.</a:t>
+            </a:r>
+          </a:p>
+        </p:txBody>
+      </p:sp>
+    </p:spTree>
+  </p:cSld>
+  <p:clrMapOvr>
+    <a:masterClrMapping/>
+  </p:clrMapOvr>
+</p:sld>
+</file>
+
+<file path=ppt/slides/slide7.xml><?xml version="1.0" encoding="utf-8"?>
+<p:sld xmlns:a="http://schemas.openxmlformats.org/drawingml/2006/main" xmlns:p="http://schemas.openxmlformats.org/presentationml/2006/main" xmlns:r="http://schemas.openxmlformats.org/officeDocument/2006/relationships">
+  <p:cSld>
+    <p:spTree>
+      <p:nvGrpSpPr>
+        <p:cNvPr id="1" name=""/>
+        <p:cNvGrpSpPr/>
+        <p:nvPr/>
+      </p:nvGrpSpPr>
+      <p:grpSpPr/>
+      <p:sp>
+        <p:nvSpPr>
+          <p:cNvPr id="2" name="TextBox 1"/>
+          <p:cNvSpPr txBox="1"/>
+          <p:nvPr/>
+        </p:nvSpPr>
+        <p:spPr>
+          <a:xfrm>
+            <a:off x="502920" y="256032"/>
+            <a:ext cx="8321040" cy="420624"/>
+          </a:xfrm>
+          <a:prstGeom prst="rect">
+            <a:avLst/>
+          </a:prstGeom>
+          <a:noFill/>
+        </p:spPr>
+        <p:txBody>
+          <a:bodyPr wrap="square" lIns="73152" rIns="73152">
+            <a:spAutoFit/>
+          </a:bodyPr>
+          <a:lstStyle/>
+          <a:p>
+            <a:r>
+              <a:rPr sz="2400" b="1">
+                <a:solidFill>
+                  <a:srgbClr val="1B2733"/>
+                </a:solidFill>
+              </a:rPr>
+              <a:t>Facilitator checklist and Python assist decision</a:t>
+            </a:r>
+          </a:p>
+        </p:txBody>
+      </p:sp>
+      <p:sp>
+        <p:nvSpPr>
+          <p:cNvPr id="3" name="TextBox 2"/>
+          <p:cNvSpPr txBox="1"/>
+          <p:nvPr/>
+        </p:nvSpPr>
+        <p:spPr>
+          <a:xfrm>
+            <a:off x="521207" y="713232"/>
+            <a:ext cx="7772400" cy="237744"/>
+          </a:xfrm>
+          <a:prstGeom prst="rect">
+            <a:avLst/>
+          </a:prstGeom>
+          <a:noFill/>
+        </p:spPr>
+        <p:txBody>
+          <a:bodyPr wrap="square" lIns="73152" rIns="73152">
+            <a:spAutoFit/>
+          </a:bodyPr>
+          <a:lstStyle/>
+          <a:p>
+            <a:r>
+              <a:rPr sz="1100" b="0">
+                <a:solidFill>
+                  <a:srgbClr val="5A636C"/>
+                </a:solidFill>
+              </a:rPr>
+              <a:t>Pareto Chart</a:t>
+            </a:r>
+          </a:p>
+        </p:txBody>
+      </p:sp>
+      <p:sp>
+        <p:nvSpPr>
+          <p:cNvPr id="4" name="Rectangle 3"/>
+          <p:cNvSpPr/>
+          <p:nvPr/>
+        </p:nvSpPr>
+        <p:spPr>
+          <a:xfrm>
+            <a:off x="502920" y="941832"/>
+            <a:ext cx="11155680" cy="27432"/>
+          </a:xfrm>
+          <a:prstGeom prst="rect">
+            <a:avLst/>
+          </a:prstGeom>
+          <a:solidFill>
+            <a:srgbClr val="427E78"/>
+          </a:solidFill>
+          <a:ln>
+            <a:noFill/>
+          </a:ln>
+        </p:spPr>
+        <p:style>
+          <a:lnRef idx="1">
+            <a:schemeClr val="accent1"/>
+          </a:lnRef>
+          <a:fillRef idx="3">
+            <a:schemeClr val="accent1"/>
+          </a:fillRef>
+          <a:effectRef idx="2">
+            <a:schemeClr val="accent1"/>
+          </a:effectRef>
+          <a:fontRef idx="minor">
+            <a:schemeClr val="lt1"/>
+          </a:fontRef>
+        </p:style>
+        <p:txBody>
+          <a:bodyPr rtlCol="0" anchor="ctr"/>
+          <a:lstStyle/>
+          <a:p>
+            <a:pPr algn="ctr"/>
+          </a:p>
+        </p:txBody>
+      </p:sp>
+      <p:sp>
+        <p:nvSpPr>
+          <p:cNvPr id="5" name="Rounded Rectangle 4"/>
+          <p:cNvSpPr/>
+          <p:nvPr/>
+        </p:nvSpPr>
+        <p:spPr>
+          <a:xfrm>
+            <a:off x="640080" y="1325880"/>
+            <a:ext cx="5212080" cy="4526280"/>
+          </a:xfrm>
+          <a:prstGeom prst="roundRect">
+            <a:avLst/>
+          </a:prstGeom>
+          <a:solidFill>
+            <a:srgbClr val="F8F9F7"/>
+          </a:solidFill>
+          <a:ln>
+            <a:solidFill>
+              <a:srgbClr val="BEC4BF"/>
+            </a:solidFill>
+          </a:ln>
+        </p:spPr>
+        <p:style>
+          <a:lnRef idx="1">
+            <a:schemeClr val="accent1"/>
+          </a:lnRef>
+          <a:fillRef idx="3">
+            <a:schemeClr val="accent1"/>
+          </a:fillRef>
+          <a:effectRef idx="2">
+            <a:schemeClr val="accent1"/>
+          </a:effectRef>
+          <a:fontRef idx="minor">
+            <a:schemeClr val="lt1"/>
+          </a:fontRef>
+        </p:style>
+        <p:txBody>
+          <a:bodyPr rtlCol="0" anchor="t" lIns="164592" rIns="164592" tIns="128016"/>
+          <a:lstStyle/>
+          <a:p>
+            <a:pPr algn="ctr"/>
+            <a:r>
+              <a:rPr b="1" sz="1500">
+                <a:solidFill>
+                  <a:srgbClr val="1B2733"/>
+                </a:solidFill>
+              </a:rPr>
+              <a:t>Facilitator checklist</a:t>
+            </a:r>
+          </a:p>
+          <a:p>
+            <a:pPr>
+              <a:defRPr sz="1100">
+                <a:solidFill>
+                  <a:srgbClr val="2D3741"/>
+                </a:solidFill>
+              </a:defRPr>
+            </a:pPr>
+            <a:r>
+              <a:t>Source and date range shown.</a:t>
+            </a:r>
+          </a:p>
+          <a:p>
+            <a:pPr>
+              <a:defRPr sz="1100">
+                <a:solidFill>
+                  <a:srgbClr val="2D3741"/>
+                </a:solidFill>
+              </a:defRPr>
+            </a:pPr>
+            <a:r>
+              <a:t>Categories clear and non-overlapping.</a:t>
+            </a:r>
+          </a:p>
+          <a:p>
+            <a:pPr>
+              <a:defRPr sz="1100">
+                <a:solidFill>
+                  <a:srgbClr val="2D3741"/>
+                </a:solidFill>
+              </a:defRPr>
+            </a:pPr>
+            <a:r>
+              <a:t>Counts sorted descending.</a:t>
+            </a:r>
+          </a:p>
+          <a:p>
+            <a:pPr>
+              <a:defRPr sz="1100">
+                <a:solidFill>
+                  <a:srgbClr val="2D3741"/>
+                </a:solidFill>
+              </a:defRPr>
+            </a:pPr>
+            <a:r>
+              <a:t>Conclusion and next action written.</a:t>
+            </a:r>
+          </a:p>
+        </p:txBody>
+      </p:sp>
+      <p:sp>
+        <p:nvSpPr>
+          <p:cNvPr id="6" name="Rounded Rectangle 5"/>
+          <p:cNvSpPr/>
+          <p:nvPr/>
+        </p:nvSpPr>
+        <p:spPr>
+          <a:xfrm>
+            <a:off x="6263640" y="1325880"/>
+            <a:ext cx="5212080" cy="4526280"/>
+          </a:xfrm>
+          <a:prstGeom prst="roundRect">
+            <a:avLst/>
+          </a:prstGeom>
+          <a:solidFill>
+            <a:srgbClr val="F8F9F7"/>
+          </a:solidFill>
+          <a:ln>
+            <a:solidFill>
+              <a:srgbClr val="BEC4BF"/>
+            </a:solidFill>
+          </a:ln>
+        </p:spPr>
+        <p:style>
+          <a:lnRef idx="1">
+            <a:schemeClr val="accent1"/>
+          </a:lnRef>
+          <a:fillRef idx="3">
+            <a:schemeClr val="accent1"/>
+          </a:fillRef>
+          <a:effectRef idx="2">
+            <a:schemeClr val="accent1"/>
+          </a:effectRef>
+          <a:fontRef idx="minor">
+            <a:schemeClr val="lt1"/>
+          </a:fontRef>
+        </p:style>
+        <p:txBody>
+          <a:bodyPr rtlCol="0" anchor="t" lIns="164592" rIns="164592" tIns="128016"/>
+          <a:lstStyle/>
+          <a:p>
+            <a:pPr algn="ctr"/>
+            <a:r>
+              <a:rPr b="1" sz="1500">
+                <a:solidFill>
+                  <a:srgbClr val="1B2733"/>
+                </a:solidFill>
+              </a:rPr>
+              <a:t>Python assist decision</a:t>
+            </a:r>
+          </a:p>
+          <a:p>
+            <a:pPr>
+              <a:defRPr sz="1100">
+                <a:solidFill>
+                  <a:srgbClr val="2D3741"/>
+                </a:solidFill>
+              </a:defRPr>
+            </a:pPr>
+            <a:r>
+              <a:t>PowerPoint: training, draft, and small counted tables.</a:t>
+            </a:r>
+          </a:p>
+          <a:p>
+            <a:pPr>
+              <a:defRPr sz="1100">
+                <a:solidFill>
+                  <a:srgbClr val="2D3741"/>
+                </a:solidFill>
+              </a:defRPr>
+            </a:pPr>
+            <a:r>
+              <a:t>Python: raw logs, repeated generation, validation-heavy data.</a:t>
+            </a:r>
+          </a:p>
+          <a:p>
+            <a:pPr>
+              <a:defRPr sz="1100">
+                <a:solidFill>
+                  <a:srgbClr val="2D3741"/>
+                </a:solidFill>
+              </a:defRPr>
+            </a:pPr>
+            <a:r>
+              <a:t>Level 3: Python recommended for raw or repeated chart methods.</a:t>
+            </a:r>
+          </a:p>
+          <a:p>
+            <a:pPr>
+              <a:defRPr sz="1100">
+                <a:solidFill>
+                  <a:srgbClr val="2D3741"/>
+                </a:solidFill>
+              </a:defRPr>
+            </a:pPr>
+            <a:r>
+              <a:t>Level 4: reproducible evidence package or validated path.</a:t>
+            </a:r>
+          </a:p>
+        </p:txBody>
+      </p:sp>
+      <p:sp>
+        <p:nvSpPr>
+          <p:cNvPr id="7" name="TextBox 6"/>
+          <p:cNvSpPr txBox="1"/>
+          <p:nvPr/>
+        </p:nvSpPr>
+        <p:spPr>
+          <a:xfrm>
+            <a:off x="548640" y="6355080"/>
+            <a:ext cx="10881360" cy="228600"/>
+          </a:xfrm>
+          <a:prstGeom prst="rect">
+            <a:avLst/>
+          </a:prstGeom>
+          <a:noFill/>
+        </p:spPr>
+        <p:txBody>
+          <a:bodyPr wrap="square" lIns="73152" rIns="73152">
+            <a:spAutoFit/>
+          </a:bodyPr>
+          <a:lstStyle/>
+          <a:p>
+            <a:r>
+              <a:rPr sz="800" b="0">
+                <a:solidFill>
+                  <a:srgbClr val="697077"/>
+                </a:solidFill>
+              </a:rPr>
+              <a:t>pareto_chart_method_template | pareto_chart | Final data-dependent evidence belongs in the evidence package.</a:t>
+            </a:r>
+          </a:p>
+        </p:txBody>
+      </p:sp>
+    </p:spTree>
+  </p:cSld>
+  <p:clrMapOvr>
+    <a:masterClrMapping/>
+  </p:clrMapOvr>
+</p:sld>
+</file>
+
+<file path=ppt/slides/slide8.xml><?xml version="1.0" encoding="utf-8"?>
+<p:sld xmlns:a="http://schemas.openxmlformats.org/drawingml/2006/main" xmlns:p="http://schemas.openxmlformats.org/presentationml/2006/main" xmlns:r="http://schemas.openxmlformats.org/officeDocument/2006/relationships">
+  <p:cSld>
+    <p:spTree>
+      <p:nvGrpSpPr>
+        <p:cNvPr id="1" name=""/>
+        <p:cNvGrpSpPr/>
+        <p:nvPr/>
+      </p:nvGrpSpPr>
+      <p:grpSpPr/>
+      <p:sp>
+        <p:nvSpPr>
+          <p:cNvPr id="2" name="TextBox 1"/>
+          <p:cNvSpPr txBox="1"/>
+          <p:nvPr/>
+        </p:nvSpPr>
+        <p:spPr>
+          <a:xfrm>
+            <a:off x="502920" y="256032"/>
+            <a:ext cx="8321040" cy="420624"/>
+          </a:xfrm>
+          <a:prstGeom prst="rect">
+            <a:avLst/>
+          </a:prstGeom>
+          <a:noFill/>
+        </p:spPr>
+        <p:txBody>
+          <a:bodyPr wrap="square" lIns="73152" rIns="73152">
+            <a:spAutoFit/>
+          </a:bodyPr>
+          <a:lstStyle/>
+          <a:p>
+            <a:r>
+              <a:rPr sz="2400" b="1">
+                <a:solidFill>
+                  <a:srgbClr val="1B2733"/>
+                </a:solidFill>
+              </a:rPr>
+              <a:t>Evidence/source note</a:t>
+            </a:r>
+          </a:p>
+        </p:txBody>
+      </p:sp>
+      <p:sp>
+        <p:nvSpPr>
+          <p:cNvPr id="3" name="TextBox 2"/>
+          <p:cNvSpPr txBox="1"/>
+          <p:nvPr/>
+        </p:nvSpPr>
+        <p:spPr>
+          <a:xfrm>
+            <a:off x="521207" y="713232"/>
+            <a:ext cx="7772400" cy="237744"/>
+          </a:xfrm>
+          <a:prstGeom prst="rect">
+            <a:avLst/>
+          </a:prstGeom>
+          <a:noFill/>
+        </p:spPr>
+        <p:txBody>
+          <a:bodyPr wrap="square" lIns="73152" rIns="73152">
+            <a:spAutoFit/>
+          </a:bodyPr>
+          <a:lstStyle/>
+          <a:p>
+            <a:r>
+              <a:rPr sz="1100" b="0">
+                <a:solidFill>
+                  <a:srgbClr val="5A636C"/>
+                </a:solidFill>
+              </a:rPr>
+              <a:t>Pareto Chart</a:t>
+            </a:r>
+          </a:p>
+        </p:txBody>
+      </p:sp>
+      <p:sp>
+        <p:nvSpPr>
+          <p:cNvPr id="4" name="Rectangle 3"/>
+          <p:cNvSpPr/>
+          <p:nvPr/>
+        </p:nvSpPr>
+        <p:spPr>
+          <a:xfrm>
+            <a:off x="502920" y="941832"/>
+            <a:ext cx="11155680" cy="27432"/>
+          </a:xfrm>
+          <a:prstGeom prst="rect">
+            <a:avLst/>
+          </a:prstGeom>
+          <a:solidFill>
+            <a:srgbClr val="427E78"/>
+          </a:solidFill>
+          <a:ln>
+            <a:noFill/>
+          </a:ln>
+        </p:spPr>
+        <p:style>
+          <a:lnRef idx="1">
+            <a:schemeClr val="accent1"/>
+          </a:lnRef>
+          <a:fillRef idx="3">
+            <a:schemeClr val="accent1"/>
+          </a:fillRef>
+          <a:effectRef idx="2">
+            <a:schemeClr val="accent1"/>
+          </a:effectRef>
+          <a:fontRef idx="minor">
+            <a:schemeClr val="lt1"/>
+          </a:fontRef>
+        </p:style>
+        <p:txBody>
+          <a:bodyPr rtlCol="0" anchor="ctr"/>
+          <a:lstStyle/>
+          <a:p>
+            <a:pPr algn="ctr"/>
+          </a:p>
+        </p:txBody>
+      </p:sp>
+      <p:sp>
+        <p:nvSpPr>
+          <p:cNvPr id="5" name="Rounded Rectangle 4"/>
+          <p:cNvSpPr/>
+          <p:nvPr/>
+        </p:nvSpPr>
+        <p:spPr>
+          <a:xfrm>
+            <a:off x="640080" y="1325880"/>
+            <a:ext cx="5212080" cy="4526280"/>
+          </a:xfrm>
+          <a:prstGeom prst="roundRect">
+            <a:avLst/>
+          </a:prstGeom>
+          <a:solidFill>
+            <a:srgbClr val="F8F9F7"/>
+          </a:solidFill>
+          <a:ln>
+            <a:solidFill>
+              <a:srgbClr val="BEC4BF"/>
+            </a:solidFill>
+          </a:ln>
+        </p:spPr>
+        <p:style>
+          <a:lnRef idx="1">
+            <a:schemeClr val="accent1"/>
+          </a:lnRef>
+          <a:fillRef idx="3">
+            <a:schemeClr val="accent1"/>
+          </a:fillRef>
+          <a:effectRef idx="2">
+            <a:schemeClr val="accent1"/>
+          </a:effectRef>
+          <a:fontRef idx="minor">
+            <a:schemeClr val="lt1"/>
+          </a:fontRef>
+        </p:style>
+        <p:txBody>
+          <a:bodyPr rtlCol="0" anchor="t" lIns="164592" rIns="164592" tIns="128016"/>
+          <a:lstStyle/>
+          <a:p>
+            <a:pPr algn="ctr"/>
+            <a:r>
+              <a:rPr b="1" sz="1500">
+                <a:solidFill>
+                  <a:srgbClr val="1B2733"/>
+                </a:solidFill>
+              </a:rPr>
+              <a:t>Evidence levels</a:t>
+            </a:r>
+          </a:p>
+          <a:p>
+            <a:pPr>
+              <a:defRPr sz="1100">
+                <a:solidFill>
+                  <a:srgbClr val="2D3741"/>
+                </a:solidFill>
+              </a:defRPr>
+            </a:pPr>
+            <a:r>
+              <a:t>Level 1: teaching/draft PowerPoint edits.</a:t>
+            </a:r>
+          </a:p>
+          <a:p>
+            <a:pPr>
+              <a:defRPr sz="1100">
+                <a:solidFill>
+                  <a:srgbClr val="2D3741"/>
+                </a:solidFill>
+              </a:defRPr>
+            </a:pPr>
+            <a:r>
+              <a:t>Level 2: normal project with source and checklist evidence.</a:t>
+            </a:r>
+          </a:p>
+          <a:p>
+            <a:pPr>
+              <a:defRPr sz="1100">
+                <a:solidFill>
+                  <a:srgbClr val="2D3741"/>
+                </a:solidFill>
+              </a:defRPr>
+            </a:pPr>
+            <a:r>
+              <a:t>Level 3: formal review with source data and calculation table.</a:t>
+            </a:r>
+          </a:p>
+          <a:p>
+            <a:pPr>
+              <a:defRPr sz="1100">
+                <a:solidFill>
+                  <a:srgbClr val="2D3741"/>
+                </a:solidFill>
+              </a:defRPr>
+            </a:pPr>
+            <a:r>
+              <a:t>Level 4: audit/high-risk reproducible evidence.</a:t>
+            </a:r>
+          </a:p>
+        </p:txBody>
+      </p:sp>
+      <p:sp>
+        <p:nvSpPr>
+          <p:cNvPr id="6" name="Rounded Rectangle 5"/>
+          <p:cNvSpPr/>
+          <p:nvPr/>
+        </p:nvSpPr>
+        <p:spPr>
+          <a:xfrm>
+            <a:off x="6263640" y="1325880"/>
+            <a:ext cx="5212080" cy="4526280"/>
+          </a:xfrm>
+          <a:prstGeom prst="roundRect">
+            <a:avLst/>
+          </a:prstGeom>
+          <a:solidFill>
+            <a:srgbClr val="F8F9F7"/>
+          </a:solidFill>
+          <a:ln>
+            <a:solidFill>
+              <a:srgbClr val="BEC4BF"/>
+            </a:solidFill>
+          </a:ln>
+        </p:spPr>
+        <p:style>
+          <a:lnRef idx="1">
+            <a:schemeClr val="accent1"/>
+          </a:lnRef>
+          <a:fillRef idx="3">
+            <a:schemeClr val="accent1"/>
+          </a:fillRef>
+          <a:effectRef idx="2">
+            <a:schemeClr val="accent1"/>
+          </a:effectRef>
+          <a:fontRef idx="minor">
+            <a:schemeClr val="lt1"/>
+          </a:fontRef>
+        </p:style>
+        <p:txBody>
+          <a:bodyPr rtlCol="0" anchor="t" lIns="164592" rIns="164592" tIns="128016"/>
+          <a:lstStyle/>
+          <a:p>
+            <a:pPr algn="ctr"/>
+            <a:r>
+              <a:rPr b="1" sz="1500">
+                <a:solidFill>
+                  <a:srgbClr val="1B2733"/>
+                </a:solidFill>
+              </a:rPr>
+              <a:t>Record on the slide</a:t>
+            </a:r>
+          </a:p>
+          <a:p>
+            <a:pPr>
+              <a:defRPr sz="1100">
+                <a:solidFill>
+                  <a:srgbClr val="2D3741"/>
+                </a:solidFill>
+              </a:defRPr>
+            </a:pPr>
+            <a:r>
+              <a:t>Source.</a:t>
+            </a:r>
+          </a:p>
+          <a:p>
+            <a:pPr>
+              <a:defRPr sz="1100">
+                <a:solidFill>
+                  <a:srgbClr val="2D3741"/>
+                </a:solidFill>
+              </a:defRPr>
+            </a:pPr>
+            <a:r>
+              <a:t>Date range.</a:t>
+            </a:r>
+          </a:p>
+          <a:p>
+            <a:pPr>
+              <a:defRPr sz="1100">
+                <a:solidFill>
+                  <a:srgbClr val="2D3741"/>
+                </a:solidFill>
+              </a:defRPr>
+            </a:pPr>
+            <a:r>
+              <a:t>Filters and assumptions.</a:t>
+            </a:r>
+          </a:p>
+          <a:p>
+            <a:pPr>
+              <a:defRPr sz="1100">
+                <a:solidFill>
+                  <a:srgbClr val="2D3741"/>
+                </a:solidFill>
+              </a:defRPr>
+            </a:pPr>
+            <a:r>
+              <a:t>Calculation notes.</a:t>
+            </a:r>
+          </a:p>
+          <a:p>
+            <a:pPr>
+              <a:defRPr sz="1100">
+                <a:solidFill>
+                  <a:srgbClr val="2D3741"/>
+                </a:solidFill>
+              </a:defRPr>
+            </a:pPr>
+            <a:r>
+              <a:t>Prepared by/date.</a:t>
+            </a:r>
+          </a:p>
+        </p:txBody>
+      </p:sp>
+      <p:sp>
+        <p:nvSpPr>
+          <p:cNvPr id="7" name="TextBox 6"/>
+          <p:cNvSpPr txBox="1"/>
+          <p:nvPr/>
+        </p:nvSpPr>
+        <p:spPr>
+          <a:xfrm>
+            <a:off x="548640" y="6355080"/>
+            <a:ext cx="10881360" cy="228600"/>
+          </a:xfrm>
+          <a:prstGeom prst="rect">
+            <a:avLst/>
+          </a:prstGeom>
+          <a:noFill/>
+        </p:spPr>
+        <p:txBody>
+          <a:bodyPr wrap="square" lIns="73152" rIns="73152">
+            <a:spAutoFit/>
+          </a:bodyPr>
+          <a:lstStyle/>
+          <a:p>
+            <a:r>
+              <a:rPr sz="800" b="0">
+                <a:solidFill>
+                  <a:srgbClr val="697077"/>
+                </a:solidFill>
+              </a:rPr>
+              <a:t>pareto_chart_method_template | pareto_chart | Final data-dependent evidence belongs in the evidence package.</a:t>
+            </a:r>
+          </a:p>
+        </p:txBody>
+      </p:sp>
+    </p:spTree>
+  </p:cSld>
+  <p:clrMapOvr>
+    <a:masterClrMapping/>
+  </p:clrMapOvr>
+</p:sld>
+</file>
+
+<file path=ppt/slides/slide9.xml><?xml version="1.0" encoding="utf-8"?>
+<p:sld xmlns:a="http://schemas.openxmlformats.org/drawingml/2006/main" xmlns:p="http://schemas.openxmlformats.org/presentationml/2006/main" xmlns:r="http://schemas.openxmlformats.org/officeDocument/2006/relationships">
+  <p:cSld>
+    <p:spTree>
+      <p:nvGrpSpPr>
+        <p:cNvPr id="1" name=""/>
+        <p:cNvGrpSpPr/>
+        <p:nvPr/>
+      </p:nvGrpSpPr>
+      <p:grpSpPr/>
+      <p:sp>
+        <p:nvSpPr>
+          <p:cNvPr id="2" name="TextBox 1"/>
+          <p:cNvSpPr txBox="1"/>
+          <p:nvPr/>
+        </p:nvSpPr>
+        <p:spPr>
+          <a:xfrm>
+            <a:off x="502920" y="256032"/>
+            <a:ext cx="8321040" cy="420624"/>
+          </a:xfrm>
+          <a:prstGeom prst="rect">
+            <a:avLst/>
+          </a:prstGeom>
+          <a:noFill/>
+        </p:spPr>
+        <p:txBody>
+          <a:bodyPr wrap="square" lIns="73152" rIns="73152">
+            <a:spAutoFit/>
+          </a:bodyPr>
+          <a:lstStyle/>
+          <a:p>
+            <a:r>
+              <a:rPr sz="2400" b="1">
+                <a:solidFill>
+                  <a:srgbClr val="1B2733"/>
+                </a:solidFill>
+              </a:rPr>
+              <a:t>Completed demo example - DEMO EXAMPLE - not project evidence</a:t>
+            </a:r>
+          </a:p>
+        </p:txBody>
+      </p:sp>
+      <p:sp>
+        <p:nvSpPr>
+          <p:cNvPr id="3" name="TextBox 2"/>
+          <p:cNvSpPr txBox="1"/>
+          <p:nvPr/>
+        </p:nvSpPr>
+        <p:spPr>
+          <a:xfrm>
+            <a:off x="521207" y="713232"/>
+            <a:ext cx="7772400" cy="237744"/>
+          </a:xfrm>
+          <a:prstGeom prst="rect">
+            <a:avLst/>
+          </a:prstGeom>
+          <a:noFill/>
+        </p:spPr>
+        <p:txBody>
+          <a:bodyPr wrap="square" lIns="73152" rIns="73152">
+            <a:spAutoFit/>
+          </a:bodyPr>
+          <a:lstStyle/>
+          <a:p>
+            <a:r>
+              <a:rPr sz="1100" b="0">
+                <a:solidFill>
+                  <a:srgbClr val="5A636C"/>
+                </a:solidFill>
+              </a:rPr>
+              <a:t>Pareto Chart</a:t>
+            </a:r>
+          </a:p>
+        </p:txBody>
+      </p:sp>
+      <p:sp>
+        <p:nvSpPr>
+          <p:cNvPr id="4" name="Rectangle 3"/>
+          <p:cNvSpPr/>
+          <p:nvPr/>
+        </p:nvSpPr>
+        <p:spPr>
+          <a:xfrm>
+            <a:off x="502920" y="941832"/>
+            <a:ext cx="11155680" cy="27432"/>
+          </a:xfrm>
+          <a:prstGeom prst="rect">
+            <a:avLst/>
+          </a:prstGeom>
+          <a:solidFill>
+            <a:srgbClr val="427E78"/>
+          </a:solidFill>
+          <a:ln>
+            <a:noFill/>
+          </a:ln>
+        </p:spPr>
+        <p:style>
+          <a:lnRef idx="1">
+            <a:schemeClr val="accent1"/>
+          </a:lnRef>
+          <a:fillRef idx="3">
+            <a:schemeClr val="accent1"/>
+          </a:fillRef>
+          <a:effectRef idx="2">
+            <a:schemeClr val="accent1"/>
+          </a:effectRef>
+          <a:fontRef idx="minor">
+            <a:schemeClr val="lt1"/>
+          </a:fontRef>
+        </p:style>
+        <p:txBody>
+          <a:bodyPr rtlCol="0" anchor="ctr"/>
+          <a:lstStyle/>
+          <a:p>
+            <a:pPr algn="ctr"/>
+          </a:p>
+        </p:txBody>
+      </p:sp>
+      <p:sp>
+        <p:nvSpPr>
+          <p:cNvPr id="5" name="Rounded Rectangle 4"/>
+          <p:cNvSpPr/>
+          <p:nvPr/>
+        </p:nvSpPr>
+        <p:spPr>
+          <a:xfrm>
             <a:off x="640080" y="1051560"/>
-            <a:ext cx="4754880" cy="329184"/>
+            <a:ext cx="3840480" cy="329184"/>
           </a:xfrm>
           <a:prstGeom prst="roundRect">
             <a:avLst/>
@@ -4946,7 +7136,7 @@
                   <a:srgbClr val="664B11"/>
                 </a:solidFill>
               </a:rPr>
-              <a:t>Replace demo content with project evidence</a:t>
+              <a:t>DEMO EXAMPLE - not project evidence</a:t>
             </a:r>
           </a:p>
         </p:txBody>
@@ -4999,67 +7189,79 @@
                   <a:srgbClr val="1B2733"/>
                 </a:solidFill>
               </a:rPr>
-              <a:t>Project slide checklist</a:t>
-            </a:r>
-          </a:p>
-          <a:p>
-            <a:pPr>
-              <a:defRPr sz="1100">
-                <a:solidFill>
-                  <a:srgbClr val="2D3741"/>
-                </a:solidFill>
-              </a:defRPr>
-            </a:pPr>
-            <a:r>
-              <a:t>Replace the sample defect rows with project data.</a:t>
-            </a:r>
-          </a:p>
-          <a:p>
-            <a:pPr>
-              <a:defRPr sz="1100">
-                <a:solidFill>
-                  <a:srgbClr val="2D3741"/>
-                </a:solidFill>
-              </a:defRPr>
-            </a:pPr>
-            <a:r>
-              <a:t>For final evidence, regenerate the chart through Python.</a:t>
-            </a:r>
-          </a:p>
-          <a:p>
-            <a:pPr>
-              <a:defRPr sz="1100">
-                <a:solidFill>
-                  <a:srgbClr val="2D3741"/>
-                </a:solidFill>
-              </a:defRPr>
-            </a:pPr>
-            <a:r>
-              <a:t>Paste deterministic caption in {{caption}}.</a:t>
-            </a:r>
-          </a:p>
-          <a:p>
-            <a:pPr>
-              <a:defRPr sz="1100">
-                <a:solidFill>
-                  <a:srgbClr val="2D3741"/>
-                </a:solidFill>
-              </a:defRPr>
-            </a:pPr>
-            <a:r>
-              <a:t>Preserve source and filters in {{data_context}}.</a:t>
-            </a:r>
-          </a:p>
-          <a:p>
-            <a:pPr>
-              <a:defRPr sz="1100">
-                <a:solidFill>
-                  <a:srgbClr val="2D3741"/>
-                </a:solidFill>
-              </a:defRPr>
-            </a:pPr>
-            <a:r>
-              <a:t>Carry warning state in {{warnings}}.</a:t>
+              <a:t>Demo structure</a:t>
+            </a:r>
+          </a:p>
+          <a:p>
+            <a:pPr>
+              <a:defRPr sz="1100">
+                <a:solidFill>
+                  <a:srgbClr val="2D3741"/>
+                </a:solidFill>
+              </a:defRPr>
+            </a:pPr>
+            <a:r>
+              <a:t>Change data only: edit the chart data table or regenerate from Python.</a:t>
+            </a:r>
+          </a:p>
+          <a:p>
+            <a:pPr>
+              <a:defRPr sz="1100">
+                <a:solidFill>
+                  <a:srgbClr val="2D3741"/>
+                </a:solidFill>
+              </a:defRPr>
+            </a:pPr>
+            <a:r>
+              <a:t>Generated chart image slot: {{chart_image}}</a:t>
+            </a:r>
+          </a:p>
+          <a:p>
+            <a:pPr>
+              <a:defRPr sz="1100">
+                <a:solidFill>
+                  <a:srgbClr val="2D3741"/>
+                </a:solidFill>
+              </a:defRPr>
+            </a:pPr>
+            <a:r>
+              <a:t>Calculated table reference: {{calculated_table}}</a:t>
+            </a:r>
+          </a:p>
+          <a:p>
+            <a:pPr>
+              <a:defRPr sz="1100">
+                <a:solidFill>
+                  <a:srgbClr val="2D3741"/>
+                </a:solidFill>
+              </a:defRPr>
+            </a:pPr>
+            <a:r>
+              <a:t>Caption from evidence package: {{caption}}</a:t>
+            </a:r>
+          </a:p>
+          <a:p>
+            <a:pPr>
+              <a:defRPr sz="1100">
+                <a:solidFill>
+                  <a:srgbClr val="2D3741"/>
+                </a:solidFill>
+              </a:defRPr>
+            </a:pPr>
+            <a:r>
+              <a:t>Data context and filters: {{data_context}}</a:t>
+            </a:r>
+          </a:p>
+          <a:p>
+            <a:pPr>
+              <a:defRPr sz="1100">
+                <a:solidFill>
+                  <a:srgbClr val="2D3741"/>
+                </a:solidFill>
+              </a:defRPr>
+            </a:pPr>
+            <a:r>
+              <a:t>Warnings and cautions: {{warnings}}</a:t>
             </a:r>
           </a:p>
         </p:txBody>

</xml_diff>

<commit_message>
M5: strengthen Pareto chart template quality
</commit_message>
<xml_diff>
--- a/templates/ppt/methods/pareto-chart-template.pptx
+++ b/templates/ppt/methods/pareto-chart-template.pptx
@@ -15,6 +15,9 @@
     <p:sldId id="263" r:id="rId14"/>
     <p:sldId id="264" r:id="rId15"/>
     <p:sldId id="265" r:id="rId16"/>
+    <p:sldId id="266" r:id="rId17"/>
+    <p:sldId id="267" r:id="rId18"/>
+    <p:sldId id="268" r:id="rId19"/>
   </p:sldIdLst>
   <p:sldSz cx="12191999" cy="6858000" type="screen4x3"/>
   <p:notesSz cx="6858000" cy="9144000"/>
@@ -117,6 +120,146 @@
 </file>
 
 <file path=ppt/charts/chart1.xml><?xml version="1.0" encoding="utf-8"?>
+<c:chartSpace xmlns:c="http://schemas.openxmlformats.org/drawingml/2006/chart" xmlns:a="http://schemas.openxmlformats.org/drawingml/2006/main" xmlns:r="http://schemas.openxmlformats.org/officeDocument/2006/relationships">
+  <c:date1904 val="0"/>
+  <c:chart>
+    <c:autoTitleDeleted val="0"/>
+    <c:plotArea>
+      <c:barChart>
+        <c:barDir val="col"/>
+        <c:grouping val="clustered"/>
+        <c:ser>
+          <c:idx val="0"/>
+          <c:order val="0"/>
+          <c:tx>
+            <c:strRef>
+              <c:f>Sheet1!$B$1</c:f>
+              <c:strCache>
+                <c:ptCount val="1"/>
+                <c:pt idx="0">
+                  <c:v>Count</c:v>
+                </c:pt>
+              </c:strCache>
+            </c:strRef>
+          </c:tx>
+          <c:cat>
+            <c:strRef>
+              <c:f>Sheet1!$A$2:$A$6</c:f>
+              <c:strCache>
+                <c:ptCount val="5"/>
+                <c:pt idx="0">
+                  <c:v>Wrong label</c:v>
+                </c:pt>
+                <c:pt idx="1">
+                  <c:v>Missing label</c:v>
+                </c:pt>
+                <c:pt idx="2">
+                  <c:v>Damaged barcode</c:v>
+                </c:pt>
+                <c:pt idx="3">
+                  <c:v>Wrong carton</c:v>
+                </c:pt>
+                <c:pt idx="4">
+                  <c:v>Other</c:v>
+                </c:pt>
+              </c:strCache>
+            </c:strRef>
+          </c:cat>
+          <c:val>
+            <c:numRef>
+              <c:f>Sheet1!$B$2:$B$6</c:f>
+              <c:numCache>
+                <c:formatCode>General</c:formatCode>
+                <c:ptCount val="5"/>
+                <c:pt idx="0">
+                  <c:v>42</c:v>
+                </c:pt>
+                <c:pt idx="1">
+                  <c:v>27</c:v>
+                </c:pt>
+                <c:pt idx="2">
+                  <c:v>18</c:v>
+                </c:pt>
+                <c:pt idx="3">
+                  <c:v>9</c:v>
+                </c:pt>
+                <c:pt idx="4">
+                  <c:v>4</c:v>
+                </c:pt>
+              </c:numCache>
+            </c:numRef>
+          </c:val>
+        </c:ser>
+        <c:axId val="-2068027336"/>
+        <c:axId val="-2113994440"/>
+      </c:barChart>
+      <c:catAx>
+        <c:axId val="-2068027336"/>
+        <c:scaling>
+          <c:orientation val="minMax"/>
+        </c:scaling>
+        <c:delete val="0"/>
+        <c:axPos val="b"/>
+        <c:majorTickMark val="out"/>
+        <c:minorTickMark val="none"/>
+        <c:tickLblPos val="nextTo"/>
+        <c:txPr>
+          <a:bodyPr/>
+          <a:lstStyle/>
+          <a:p>
+            <a:pPr>
+              <a:defRPr sz="800"/>
+            </a:pPr>
+          </a:p>
+        </c:txPr>
+        <c:crossAx val="-2113994440"/>
+        <c:crosses val="autoZero"/>
+        <c:auto val="1"/>
+        <c:lblAlgn val="ctr"/>
+        <c:lblOffset val="100"/>
+        <c:noMultiLvlLbl val="0"/>
+      </c:catAx>
+      <c:valAx>
+        <c:axId val="-2113994440"/>
+        <c:scaling/>
+        <c:delete val="0"/>
+        <c:axPos val="l"/>
+        <c:majorGridlines/>
+        <c:majorTickMark val="out"/>
+        <c:minorTickMark val="none"/>
+        <c:tickLblPos val="nextTo"/>
+        <c:txPr>
+          <a:bodyPr/>
+          <a:lstStyle/>
+          <a:p>
+            <a:pPr>
+              <a:defRPr sz="800"/>
+            </a:pPr>
+          </a:p>
+        </c:txPr>
+        <c:crossAx val="-2068027336"/>
+        <c:crosses val="autoZero"/>
+      </c:valAx>
+    </c:plotArea>
+    <c:dispBlanksAs val="gap"/>
+  </c:chart>
+  <c:txPr>
+    <a:bodyPr/>
+    <a:lstStyle/>
+    <a:p>
+      <a:pPr>
+        <a:defRPr sz="1800"/>
+      </a:pPr>
+      <a:endParaRPr lang="en-US"/>
+    </a:p>
+  </c:txPr>
+  <c:externalData r:id="rId1">
+    <c:autoUpdate val="0"/>
+  </c:externalData>
+</c:chartSpace>
+</file>
+
+<file path=ppt/charts/chart2.xml><?xml version="1.0" encoding="utf-8"?>
 <c:chartSpace xmlns:c="http://schemas.openxmlformats.org/drawingml/2006/chart" xmlns:a="http://schemas.openxmlformats.org/drawingml/2006/main" xmlns:r="http://schemas.openxmlformats.org/officeDocument/2006/relationships">
   <c:date1904 val="0"/>
   <c:chart>
@@ -3714,6 +3857,1229 @@
 </file>
 
 <file path=ppt/slides/slide10.xml><?xml version="1.0" encoding="utf-8"?>
+<p:sld xmlns:a="http://schemas.openxmlformats.org/drawingml/2006/main" xmlns:p="http://schemas.openxmlformats.org/presentationml/2006/main" xmlns:r="http://schemas.openxmlformats.org/officeDocument/2006/relationships">
+  <p:cSld>
+    <p:spTree>
+      <p:nvGrpSpPr>
+        <p:cNvPr id="1" name=""/>
+        <p:cNvGrpSpPr/>
+        <p:nvPr/>
+      </p:nvGrpSpPr>
+      <p:grpSpPr/>
+      <p:sp>
+        <p:nvSpPr>
+          <p:cNvPr id="2" name="TextBox 1"/>
+          <p:cNvSpPr txBox="1"/>
+          <p:nvPr/>
+        </p:nvSpPr>
+        <p:spPr>
+          <a:xfrm>
+            <a:off x="502920" y="256032"/>
+            <a:ext cx="8321040" cy="420624"/>
+          </a:xfrm>
+          <a:prstGeom prst="rect">
+            <a:avLst/>
+          </a:prstGeom>
+          <a:noFill/>
+        </p:spPr>
+        <p:txBody>
+          <a:bodyPr wrap="square" lIns="73152" rIns="73152">
+            <a:spAutoFit/>
+          </a:bodyPr>
+          <a:lstStyle/>
+          <a:p>
+            <a:r>
+              <a:rPr sz="2400" b="1">
+                <a:solidFill>
+                  <a:srgbClr val="1B2733"/>
+                </a:solidFill>
+              </a:rPr>
+              <a:t>Facilitator checklist and Python assist decision</a:t>
+            </a:r>
+          </a:p>
+        </p:txBody>
+      </p:sp>
+      <p:sp>
+        <p:nvSpPr>
+          <p:cNvPr id="3" name="TextBox 2"/>
+          <p:cNvSpPr txBox="1"/>
+          <p:nvPr/>
+        </p:nvSpPr>
+        <p:spPr>
+          <a:xfrm>
+            <a:off x="521207" y="713232"/>
+            <a:ext cx="7772400" cy="237744"/>
+          </a:xfrm>
+          <a:prstGeom prst="rect">
+            <a:avLst/>
+          </a:prstGeom>
+          <a:noFill/>
+        </p:spPr>
+        <p:txBody>
+          <a:bodyPr wrap="square" lIns="73152" rIns="73152">
+            <a:spAutoFit/>
+          </a:bodyPr>
+          <a:lstStyle/>
+          <a:p>
+            <a:r>
+              <a:rPr sz="1100" b="0">
+                <a:solidFill>
+                  <a:srgbClr val="5A636C"/>
+                </a:solidFill>
+              </a:rPr>
+              <a:t>Pareto Chart</a:t>
+            </a:r>
+          </a:p>
+        </p:txBody>
+      </p:sp>
+      <p:sp>
+        <p:nvSpPr>
+          <p:cNvPr id="4" name="Rectangle 3"/>
+          <p:cNvSpPr/>
+          <p:nvPr/>
+        </p:nvSpPr>
+        <p:spPr>
+          <a:xfrm>
+            <a:off x="502920" y="941832"/>
+            <a:ext cx="11155680" cy="27432"/>
+          </a:xfrm>
+          <a:prstGeom prst="rect">
+            <a:avLst/>
+          </a:prstGeom>
+          <a:solidFill>
+            <a:srgbClr val="427E78"/>
+          </a:solidFill>
+          <a:ln>
+            <a:noFill/>
+          </a:ln>
+        </p:spPr>
+        <p:style>
+          <a:lnRef idx="1">
+            <a:schemeClr val="accent1"/>
+          </a:lnRef>
+          <a:fillRef idx="3">
+            <a:schemeClr val="accent1"/>
+          </a:fillRef>
+          <a:effectRef idx="2">
+            <a:schemeClr val="accent1"/>
+          </a:effectRef>
+          <a:fontRef idx="minor">
+            <a:schemeClr val="lt1"/>
+          </a:fontRef>
+        </p:style>
+        <p:txBody>
+          <a:bodyPr rtlCol="0" anchor="ctr"/>
+          <a:lstStyle/>
+          <a:p>
+            <a:pPr algn="ctr"/>
+          </a:p>
+        </p:txBody>
+      </p:sp>
+      <p:sp>
+        <p:nvSpPr>
+          <p:cNvPr id="5" name="Rounded Rectangle 4"/>
+          <p:cNvSpPr/>
+          <p:nvPr/>
+        </p:nvSpPr>
+        <p:spPr>
+          <a:xfrm>
+            <a:off x="640080" y="1325880"/>
+            <a:ext cx="5212080" cy="4526280"/>
+          </a:xfrm>
+          <a:prstGeom prst="roundRect">
+            <a:avLst/>
+          </a:prstGeom>
+          <a:solidFill>
+            <a:srgbClr val="F8F9F7"/>
+          </a:solidFill>
+          <a:ln>
+            <a:solidFill>
+              <a:srgbClr val="BEC4BF"/>
+            </a:solidFill>
+          </a:ln>
+        </p:spPr>
+        <p:style>
+          <a:lnRef idx="1">
+            <a:schemeClr val="accent1"/>
+          </a:lnRef>
+          <a:fillRef idx="3">
+            <a:schemeClr val="accent1"/>
+          </a:fillRef>
+          <a:effectRef idx="2">
+            <a:schemeClr val="accent1"/>
+          </a:effectRef>
+          <a:fontRef idx="minor">
+            <a:schemeClr val="lt1"/>
+          </a:fontRef>
+        </p:style>
+        <p:txBody>
+          <a:bodyPr rtlCol="0" anchor="t" lIns="164592" rIns="164592" tIns="128016"/>
+          <a:lstStyle/>
+          <a:p>
+            <a:pPr algn="ctr"/>
+            <a:r>
+              <a:rPr b="1" sz="1500">
+                <a:solidFill>
+                  <a:srgbClr val="1B2733"/>
+                </a:solidFill>
+              </a:rPr>
+              <a:t>Facilitator checklist</a:t>
+            </a:r>
+          </a:p>
+          <a:p>
+            <a:pPr>
+              <a:defRPr sz="1100">
+                <a:solidFill>
+                  <a:srgbClr val="2D3741"/>
+                </a:solidFill>
+              </a:defRPr>
+            </a:pPr>
+            <a:r>
+              <a:t>Source and date range shown.</a:t>
+            </a:r>
+          </a:p>
+          <a:p>
+            <a:pPr>
+              <a:defRPr sz="1100">
+                <a:solidFill>
+                  <a:srgbClr val="2D3741"/>
+                </a:solidFill>
+              </a:defRPr>
+            </a:pPr>
+            <a:r>
+              <a:t>Categories clear and non-overlapping.</a:t>
+            </a:r>
+          </a:p>
+          <a:p>
+            <a:pPr>
+              <a:defRPr sz="1100">
+                <a:solidFill>
+                  <a:srgbClr val="2D3741"/>
+                </a:solidFill>
+              </a:defRPr>
+            </a:pPr>
+            <a:r>
+              <a:t>Counts sorted descending.</a:t>
+            </a:r>
+          </a:p>
+          <a:p>
+            <a:pPr>
+              <a:defRPr sz="1100">
+                <a:solidFill>
+                  <a:srgbClr val="2D3741"/>
+                </a:solidFill>
+              </a:defRPr>
+            </a:pPr>
+            <a:r>
+              <a:t>Conclusion and next action written.</a:t>
+            </a:r>
+          </a:p>
+        </p:txBody>
+      </p:sp>
+      <p:sp>
+        <p:nvSpPr>
+          <p:cNvPr id="6" name="Rounded Rectangle 5"/>
+          <p:cNvSpPr/>
+          <p:nvPr/>
+        </p:nvSpPr>
+        <p:spPr>
+          <a:xfrm>
+            <a:off x="6263640" y="1325880"/>
+            <a:ext cx="5212080" cy="4526280"/>
+          </a:xfrm>
+          <a:prstGeom prst="roundRect">
+            <a:avLst/>
+          </a:prstGeom>
+          <a:solidFill>
+            <a:srgbClr val="F8F9F7"/>
+          </a:solidFill>
+          <a:ln>
+            <a:solidFill>
+              <a:srgbClr val="BEC4BF"/>
+            </a:solidFill>
+          </a:ln>
+        </p:spPr>
+        <p:style>
+          <a:lnRef idx="1">
+            <a:schemeClr val="accent1"/>
+          </a:lnRef>
+          <a:fillRef idx="3">
+            <a:schemeClr val="accent1"/>
+          </a:fillRef>
+          <a:effectRef idx="2">
+            <a:schemeClr val="accent1"/>
+          </a:effectRef>
+          <a:fontRef idx="minor">
+            <a:schemeClr val="lt1"/>
+          </a:fontRef>
+        </p:style>
+        <p:txBody>
+          <a:bodyPr rtlCol="0" anchor="t" lIns="164592" rIns="164592" tIns="128016"/>
+          <a:lstStyle/>
+          <a:p>
+            <a:pPr algn="ctr"/>
+            <a:r>
+              <a:rPr b="1" sz="1500">
+                <a:solidFill>
+                  <a:srgbClr val="1B2733"/>
+                </a:solidFill>
+              </a:rPr>
+              <a:t>Python assist decision</a:t>
+            </a:r>
+          </a:p>
+          <a:p>
+            <a:pPr>
+              <a:defRPr sz="1100">
+                <a:solidFill>
+                  <a:srgbClr val="2D3741"/>
+                </a:solidFill>
+              </a:defRPr>
+            </a:pPr>
+            <a:r>
+              <a:t>PowerPoint: training, draft, and small counted tables.</a:t>
+            </a:r>
+          </a:p>
+          <a:p>
+            <a:pPr>
+              <a:defRPr sz="1100">
+                <a:solidFill>
+                  <a:srgbClr val="2D3741"/>
+                </a:solidFill>
+              </a:defRPr>
+            </a:pPr>
+            <a:r>
+              <a:t>Python: raw logs, repeated generation, validation-heavy data.</a:t>
+            </a:r>
+          </a:p>
+          <a:p>
+            <a:pPr>
+              <a:defRPr sz="1100">
+                <a:solidFill>
+                  <a:srgbClr val="2D3741"/>
+                </a:solidFill>
+              </a:defRPr>
+            </a:pPr>
+            <a:r>
+              <a:t>Level 3: Python recommended for raw or repeated chart methods.</a:t>
+            </a:r>
+          </a:p>
+          <a:p>
+            <a:pPr>
+              <a:defRPr sz="1100">
+                <a:solidFill>
+                  <a:srgbClr val="2D3741"/>
+                </a:solidFill>
+              </a:defRPr>
+            </a:pPr>
+            <a:r>
+              <a:t>Level 4: reproducible evidence package or validated path.</a:t>
+            </a:r>
+          </a:p>
+        </p:txBody>
+      </p:sp>
+      <p:sp>
+        <p:nvSpPr>
+          <p:cNvPr id="7" name="TextBox 6"/>
+          <p:cNvSpPr txBox="1"/>
+          <p:nvPr/>
+        </p:nvSpPr>
+        <p:spPr>
+          <a:xfrm>
+            <a:off x="548640" y="6355080"/>
+            <a:ext cx="10881360" cy="228600"/>
+          </a:xfrm>
+          <a:prstGeom prst="rect">
+            <a:avLst/>
+          </a:prstGeom>
+          <a:noFill/>
+        </p:spPr>
+        <p:txBody>
+          <a:bodyPr wrap="square" lIns="73152" rIns="73152">
+            <a:spAutoFit/>
+          </a:bodyPr>
+          <a:lstStyle/>
+          <a:p>
+            <a:r>
+              <a:rPr sz="800" b="0">
+                <a:solidFill>
+                  <a:srgbClr val="697077"/>
+                </a:solidFill>
+              </a:rPr>
+              <a:t>pareto_chart_method_template | pareto_chart | Final data-dependent evidence belongs in the evidence package.</a:t>
+            </a:r>
+          </a:p>
+        </p:txBody>
+      </p:sp>
+    </p:spTree>
+  </p:cSld>
+  <p:clrMapOvr>
+    <a:masterClrMapping/>
+  </p:clrMapOvr>
+</p:sld>
+</file>
+
+<file path=ppt/slides/slide11.xml><?xml version="1.0" encoding="utf-8"?>
+<p:sld xmlns:a="http://schemas.openxmlformats.org/drawingml/2006/main" xmlns:p="http://schemas.openxmlformats.org/presentationml/2006/main" xmlns:r="http://schemas.openxmlformats.org/officeDocument/2006/relationships">
+  <p:cSld>
+    <p:spTree>
+      <p:nvGrpSpPr>
+        <p:cNvPr id="1" name=""/>
+        <p:cNvGrpSpPr/>
+        <p:nvPr/>
+      </p:nvGrpSpPr>
+      <p:grpSpPr/>
+      <p:sp>
+        <p:nvSpPr>
+          <p:cNvPr id="2" name="TextBox 1"/>
+          <p:cNvSpPr txBox="1"/>
+          <p:nvPr/>
+        </p:nvSpPr>
+        <p:spPr>
+          <a:xfrm>
+            <a:off x="502920" y="256032"/>
+            <a:ext cx="8321040" cy="420624"/>
+          </a:xfrm>
+          <a:prstGeom prst="rect">
+            <a:avLst/>
+          </a:prstGeom>
+          <a:noFill/>
+        </p:spPr>
+        <p:txBody>
+          <a:bodyPr wrap="square" lIns="73152" rIns="73152">
+            <a:spAutoFit/>
+          </a:bodyPr>
+          <a:lstStyle/>
+          <a:p>
+            <a:r>
+              <a:rPr sz="2400" b="1">
+                <a:solidFill>
+                  <a:srgbClr val="1B2733"/>
+                </a:solidFill>
+              </a:rPr>
+              <a:t>Evidence/source note</a:t>
+            </a:r>
+          </a:p>
+        </p:txBody>
+      </p:sp>
+      <p:sp>
+        <p:nvSpPr>
+          <p:cNvPr id="3" name="TextBox 2"/>
+          <p:cNvSpPr txBox="1"/>
+          <p:nvPr/>
+        </p:nvSpPr>
+        <p:spPr>
+          <a:xfrm>
+            <a:off x="521207" y="713232"/>
+            <a:ext cx="7772400" cy="237744"/>
+          </a:xfrm>
+          <a:prstGeom prst="rect">
+            <a:avLst/>
+          </a:prstGeom>
+          <a:noFill/>
+        </p:spPr>
+        <p:txBody>
+          <a:bodyPr wrap="square" lIns="73152" rIns="73152">
+            <a:spAutoFit/>
+          </a:bodyPr>
+          <a:lstStyle/>
+          <a:p>
+            <a:r>
+              <a:rPr sz="1100" b="0">
+                <a:solidFill>
+                  <a:srgbClr val="5A636C"/>
+                </a:solidFill>
+              </a:rPr>
+              <a:t>Pareto Chart</a:t>
+            </a:r>
+          </a:p>
+        </p:txBody>
+      </p:sp>
+      <p:sp>
+        <p:nvSpPr>
+          <p:cNvPr id="4" name="Rectangle 3"/>
+          <p:cNvSpPr/>
+          <p:nvPr/>
+        </p:nvSpPr>
+        <p:spPr>
+          <a:xfrm>
+            <a:off x="502920" y="941832"/>
+            <a:ext cx="11155680" cy="27432"/>
+          </a:xfrm>
+          <a:prstGeom prst="rect">
+            <a:avLst/>
+          </a:prstGeom>
+          <a:solidFill>
+            <a:srgbClr val="427E78"/>
+          </a:solidFill>
+          <a:ln>
+            <a:noFill/>
+          </a:ln>
+        </p:spPr>
+        <p:style>
+          <a:lnRef idx="1">
+            <a:schemeClr val="accent1"/>
+          </a:lnRef>
+          <a:fillRef idx="3">
+            <a:schemeClr val="accent1"/>
+          </a:fillRef>
+          <a:effectRef idx="2">
+            <a:schemeClr val="accent1"/>
+          </a:effectRef>
+          <a:fontRef idx="minor">
+            <a:schemeClr val="lt1"/>
+          </a:fontRef>
+        </p:style>
+        <p:txBody>
+          <a:bodyPr rtlCol="0" anchor="ctr"/>
+          <a:lstStyle/>
+          <a:p>
+            <a:pPr algn="ctr"/>
+          </a:p>
+        </p:txBody>
+      </p:sp>
+      <p:sp>
+        <p:nvSpPr>
+          <p:cNvPr id="5" name="Rounded Rectangle 4"/>
+          <p:cNvSpPr/>
+          <p:nvPr/>
+        </p:nvSpPr>
+        <p:spPr>
+          <a:xfrm>
+            <a:off x="640080" y="1325880"/>
+            <a:ext cx="5212080" cy="4526280"/>
+          </a:xfrm>
+          <a:prstGeom prst="roundRect">
+            <a:avLst/>
+          </a:prstGeom>
+          <a:solidFill>
+            <a:srgbClr val="F8F9F7"/>
+          </a:solidFill>
+          <a:ln>
+            <a:solidFill>
+              <a:srgbClr val="BEC4BF"/>
+            </a:solidFill>
+          </a:ln>
+        </p:spPr>
+        <p:style>
+          <a:lnRef idx="1">
+            <a:schemeClr val="accent1"/>
+          </a:lnRef>
+          <a:fillRef idx="3">
+            <a:schemeClr val="accent1"/>
+          </a:fillRef>
+          <a:effectRef idx="2">
+            <a:schemeClr val="accent1"/>
+          </a:effectRef>
+          <a:fontRef idx="minor">
+            <a:schemeClr val="lt1"/>
+          </a:fontRef>
+        </p:style>
+        <p:txBody>
+          <a:bodyPr rtlCol="0" anchor="t" lIns="164592" rIns="164592" tIns="128016"/>
+          <a:lstStyle/>
+          <a:p>
+            <a:pPr algn="ctr"/>
+            <a:r>
+              <a:rPr b="1" sz="1500">
+                <a:solidFill>
+                  <a:srgbClr val="1B2733"/>
+                </a:solidFill>
+              </a:rPr>
+              <a:t>Evidence levels</a:t>
+            </a:r>
+          </a:p>
+          <a:p>
+            <a:pPr>
+              <a:defRPr sz="1100">
+                <a:solidFill>
+                  <a:srgbClr val="2D3741"/>
+                </a:solidFill>
+              </a:defRPr>
+            </a:pPr>
+            <a:r>
+              <a:t>Level 1: teaching/draft PowerPoint edits.</a:t>
+            </a:r>
+          </a:p>
+          <a:p>
+            <a:pPr>
+              <a:defRPr sz="1100">
+                <a:solidFill>
+                  <a:srgbClr val="2D3741"/>
+                </a:solidFill>
+              </a:defRPr>
+            </a:pPr>
+            <a:r>
+              <a:t>Level 2: normal project with source and checklist evidence.</a:t>
+            </a:r>
+          </a:p>
+          <a:p>
+            <a:pPr>
+              <a:defRPr sz="1100">
+                <a:solidFill>
+                  <a:srgbClr val="2D3741"/>
+                </a:solidFill>
+              </a:defRPr>
+            </a:pPr>
+            <a:r>
+              <a:t>Level 3: formal review with source data and calculation table.</a:t>
+            </a:r>
+          </a:p>
+          <a:p>
+            <a:pPr>
+              <a:defRPr sz="1100">
+                <a:solidFill>
+                  <a:srgbClr val="2D3741"/>
+                </a:solidFill>
+              </a:defRPr>
+            </a:pPr>
+            <a:r>
+              <a:t>Level 4: audit/high-risk reproducible evidence.</a:t>
+            </a:r>
+          </a:p>
+        </p:txBody>
+      </p:sp>
+      <p:sp>
+        <p:nvSpPr>
+          <p:cNvPr id="6" name="Rounded Rectangle 5"/>
+          <p:cNvSpPr/>
+          <p:nvPr/>
+        </p:nvSpPr>
+        <p:spPr>
+          <a:xfrm>
+            <a:off x="6263640" y="1325880"/>
+            <a:ext cx="5212080" cy="4526280"/>
+          </a:xfrm>
+          <a:prstGeom prst="roundRect">
+            <a:avLst/>
+          </a:prstGeom>
+          <a:solidFill>
+            <a:srgbClr val="F8F9F7"/>
+          </a:solidFill>
+          <a:ln>
+            <a:solidFill>
+              <a:srgbClr val="BEC4BF"/>
+            </a:solidFill>
+          </a:ln>
+        </p:spPr>
+        <p:style>
+          <a:lnRef idx="1">
+            <a:schemeClr val="accent1"/>
+          </a:lnRef>
+          <a:fillRef idx="3">
+            <a:schemeClr val="accent1"/>
+          </a:fillRef>
+          <a:effectRef idx="2">
+            <a:schemeClr val="accent1"/>
+          </a:effectRef>
+          <a:fontRef idx="minor">
+            <a:schemeClr val="lt1"/>
+          </a:fontRef>
+        </p:style>
+        <p:txBody>
+          <a:bodyPr rtlCol="0" anchor="t" lIns="164592" rIns="164592" tIns="128016"/>
+          <a:lstStyle/>
+          <a:p>
+            <a:pPr algn="ctr"/>
+            <a:r>
+              <a:rPr b="1" sz="1500">
+                <a:solidFill>
+                  <a:srgbClr val="1B2733"/>
+                </a:solidFill>
+              </a:rPr>
+              <a:t>Record on the slide</a:t>
+            </a:r>
+          </a:p>
+          <a:p>
+            <a:pPr>
+              <a:defRPr sz="1100">
+                <a:solidFill>
+                  <a:srgbClr val="2D3741"/>
+                </a:solidFill>
+              </a:defRPr>
+            </a:pPr>
+            <a:r>
+              <a:t>Source.</a:t>
+            </a:r>
+          </a:p>
+          <a:p>
+            <a:pPr>
+              <a:defRPr sz="1100">
+                <a:solidFill>
+                  <a:srgbClr val="2D3741"/>
+                </a:solidFill>
+              </a:defRPr>
+            </a:pPr>
+            <a:r>
+              <a:t>Date range.</a:t>
+            </a:r>
+          </a:p>
+          <a:p>
+            <a:pPr>
+              <a:defRPr sz="1100">
+                <a:solidFill>
+                  <a:srgbClr val="2D3741"/>
+                </a:solidFill>
+              </a:defRPr>
+            </a:pPr>
+            <a:r>
+              <a:t>Filters and assumptions.</a:t>
+            </a:r>
+          </a:p>
+          <a:p>
+            <a:pPr>
+              <a:defRPr sz="1100">
+                <a:solidFill>
+                  <a:srgbClr val="2D3741"/>
+                </a:solidFill>
+              </a:defRPr>
+            </a:pPr>
+            <a:r>
+              <a:t>Calculation notes.</a:t>
+            </a:r>
+          </a:p>
+          <a:p>
+            <a:pPr>
+              <a:defRPr sz="1100">
+                <a:solidFill>
+                  <a:srgbClr val="2D3741"/>
+                </a:solidFill>
+              </a:defRPr>
+            </a:pPr>
+            <a:r>
+              <a:t>Prepared by/date.</a:t>
+            </a:r>
+          </a:p>
+        </p:txBody>
+      </p:sp>
+      <p:sp>
+        <p:nvSpPr>
+          <p:cNvPr id="7" name="TextBox 6"/>
+          <p:cNvSpPr txBox="1"/>
+          <p:nvPr/>
+        </p:nvSpPr>
+        <p:spPr>
+          <a:xfrm>
+            <a:off x="548640" y="6355080"/>
+            <a:ext cx="10881360" cy="228600"/>
+          </a:xfrm>
+          <a:prstGeom prst="rect">
+            <a:avLst/>
+          </a:prstGeom>
+          <a:noFill/>
+        </p:spPr>
+        <p:txBody>
+          <a:bodyPr wrap="square" lIns="73152" rIns="73152">
+            <a:spAutoFit/>
+          </a:bodyPr>
+          <a:lstStyle/>
+          <a:p>
+            <a:r>
+              <a:rPr sz="800" b="0">
+                <a:solidFill>
+                  <a:srgbClr val="697077"/>
+                </a:solidFill>
+              </a:rPr>
+              <a:t>pareto_chart_method_template | pareto_chart | Final data-dependent evidence belongs in the evidence package.</a:t>
+            </a:r>
+          </a:p>
+        </p:txBody>
+      </p:sp>
+    </p:spTree>
+  </p:cSld>
+  <p:clrMapOvr>
+    <a:masterClrMapping/>
+  </p:clrMapOvr>
+</p:sld>
+</file>
+
+<file path=ppt/slides/slide12.xml><?xml version="1.0" encoding="utf-8"?>
+<p:sld xmlns:a="http://schemas.openxmlformats.org/drawingml/2006/main" xmlns:p="http://schemas.openxmlformats.org/presentationml/2006/main" xmlns:r="http://schemas.openxmlformats.org/officeDocument/2006/relationships">
+  <p:cSld>
+    <p:spTree>
+      <p:nvGrpSpPr>
+        <p:cNvPr id="1" name=""/>
+        <p:cNvGrpSpPr/>
+        <p:nvPr/>
+      </p:nvGrpSpPr>
+      <p:grpSpPr/>
+      <p:sp>
+        <p:nvSpPr>
+          <p:cNvPr id="2" name="TextBox 1"/>
+          <p:cNvSpPr txBox="1"/>
+          <p:nvPr/>
+        </p:nvSpPr>
+        <p:spPr>
+          <a:xfrm>
+            <a:off x="502920" y="256032"/>
+            <a:ext cx="8321040" cy="420624"/>
+          </a:xfrm>
+          <a:prstGeom prst="rect">
+            <a:avLst/>
+          </a:prstGeom>
+          <a:noFill/>
+        </p:spPr>
+        <p:txBody>
+          <a:bodyPr wrap="square" lIns="73152" rIns="73152">
+            <a:spAutoFit/>
+          </a:bodyPr>
+          <a:lstStyle/>
+          <a:p>
+            <a:r>
+              <a:rPr sz="2400" b="1">
+                <a:solidFill>
+                  <a:srgbClr val="1B2733"/>
+                </a:solidFill>
+              </a:rPr>
+              <a:t>Completed demo example - DEMO EXAMPLE - not project evidence</a:t>
+            </a:r>
+          </a:p>
+        </p:txBody>
+      </p:sp>
+      <p:sp>
+        <p:nvSpPr>
+          <p:cNvPr id="3" name="TextBox 2"/>
+          <p:cNvSpPr txBox="1"/>
+          <p:nvPr/>
+        </p:nvSpPr>
+        <p:spPr>
+          <a:xfrm>
+            <a:off x="521207" y="713232"/>
+            <a:ext cx="7772400" cy="237744"/>
+          </a:xfrm>
+          <a:prstGeom prst="rect">
+            <a:avLst/>
+          </a:prstGeom>
+          <a:noFill/>
+        </p:spPr>
+        <p:txBody>
+          <a:bodyPr wrap="square" lIns="73152" rIns="73152">
+            <a:spAutoFit/>
+          </a:bodyPr>
+          <a:lstStyle/>
+          <a:p>
+            <a:r>
+              <a:rPr sz="1100" b="0">
+                <a:solidFill>
+                  <a:srgbClr val="5A636C"/>
+                </a:solidFill>
+              </a:rPr>
+              <a:t>Pareto Chart</a:t>
+            </a:r>
+          </a:p>
+        </p:txBody>
+      </p:sp>
+      <p:sp>
+        <p:nvSpPr>
+          <p:cNvPr id="4" name="Rectangle 3"/>
+          <p:cNvSpPr/>
+          <p:nvPr/>
+        </p:nvSpPr>
+        <p:spPr>
+          <a:xfrm>
+            <a:off x="502920" y="941832"/>
+            <a:ext cx="11155680" cy="27432"/>
+          </a:xfrm>
+          <a:prstGeom prst="rect">
+            <a:avLst/>
+          </a:prstGeom>
+          <a:solidFill>
+            <a:srgbClr val="427E78"/>
+          </a:solidFill>
+          <a:ln>
+            <a:noFill/>
+          </a:ln>
+        </p:spPr>
+        <p:style>
+          <a:lnRef idx="1">
+            <a:schemeClr val="accent1"/>
+          </a:lnRef>
+          <a:fillRef idx="3">
+            <a:schemeClr val="accent1"/>
+          </a:fillRef>
+          <a:effectRef idx="2">
+            <a:schemeClr val="accent1"/>
+          </a:effectRef>
+          <a:fontRef idx="minor">
+            <a:schemeClr val="lt1"/>
+          </a:fontRef>
+        </p:style>
+        <p:txBody>
+          <a:bodyPr rtlCol="0" anchor="ctr"/>
+          <a:lstStyle/>
+          <a:p>
+            <a:pPr algn="ctr"/>
+          </a:p>
+        </p:txBody>
+      </p:sp>
+      <p:sp>
+        <p:nvSpPr>
+          <p:cNvPr id="5" name="Rounded Rectangle 4"/>
+          <p:cNvSpPr/>
+          <p:nvPr/>
+        </p:nvSpPr>
+        <p:spPr>
+          <a:xfrm>
+            <a:off x="640080" y="1051560"/>
+            <a:ext cx="3840480" cy="329184"/>
+          </a:xfrm>
+          <a:prstGeom prst="roundRect">
+            <a:avLst/>
+          </a:prstGeom>
+          <a:solidFill>
+            <a:srgbClr val="FFF2CC"/>
+          </a:solidFill>
+          <a:ln>
+            <a:solidFill>
+              <a:srgbClr val="D69F2E"/>
+            </a:solidFill>
+          </a:ln>
+        </p:spPr>
+        <p:style>
+          <a:lnRef idx="1">
+            <a:schemeClr val="accent1"/>
+          </a:lnRef>
+          <a:fillRef idx="3">
+            <a:schemeClr val="accent1"/>
+          </a:fillRef>
+          <a:effectRef idx="2">
+            <a:schemeClr val="accent1"/>
+          </a:effectRef>
+          <a:fontRef idx="minor">
+            <a:schemeClr val="lt1"/>
+          </a:fontRef>
+        </p:style>
+        <p:txBody>
+          <a:bodyPr rtlCol="0" anchor="ctr"/>
+          <a:lstStyle/>
+          <a:p>
+            <a:pPr algn="ctr"/>
+            <a:r>
+              <a:rPr b="1" sz="1100">
+                <a:solidFill>
+                  <a:srgbClr val="664B11"/>
+                </a:solidFill>
+              </a:rPr>
+              <a:t>DEMO EXAMPLE - not project evidence</a:t>
+            </a:r>
+          </a:p>
+        </p:txBody>
+      </p:sp>
+      <p:sp>
+        <p:nvSpPr>
+          <p:cNvPr id="6" name="Rounded Rectangle 5"/>
+          <p:cNvSpPr/>
+          <p:nvPr/>
+        </p:nvSpPr>
+        <p:spPr>
+          <a:xfrm>
+            <a:off x="640080" y="1691640"/>
+            <a:ext cx="5394960" cy="4206240"/>
+          </a:xfrm>
+          <a:prstGeom prst="roundRect">
+            <a:avLst/>
+          </a:prstGeom>
+          <a:solidFill>
+            <a:srgbClr val="F8F9F7"/>
+          </a:solidFill>
+          <a:ln>
+            <a:solidFill>
+              <a:srgbClr val="BEC4BF"/>
+            </a:solidFill>
+          </a:ln>
+        </p:spPr>
+        <p:style>
+          <a:lnRef idx="1">
+            <a:schemeClr val="accent1"/>
+          </a:lnRef>
+          <a:fillRef idx="3">
+            <a:schemeClr val="accent1"/>
+          </a:fillRef>
+          <a:effectRef idx="2">
+            <a:schemeClr val="accent1"/>
+          </a:effectRef>
+          <a:fontRef idx="minor">
+            <a:schemeClr val="lt1"/>
+          </a:fontRef>
+        </p:style>
+        <p:txBody>
+          <a:bodyPr rtlCol="0" anchor="t" lIns="164592" rIns="164592" tIns="128016"/>
+          <a:lstStyle/>
+          <a:p>
+            <a:pPr algn="ctr"/>
+            <a:r>
+              <a:rPr b="1" sz="1500">
+                <a:solidFill>
+                  <a:srgbClr val="1B2733"/>
+                </a:solidFill>
+              </a:rPr>
+              <a:t>Demo structure</a:t>
+            </a:r>
+          </a:p>
+          <a:p>
+            <a:pPr>
+              <a:defRPr sz="1100">
+                <a:solidFill>
+                  <a:srgbClr val="2D3741"/>
+                </a:solidFill>
+              </a:defRPr>
+            </a:pPr>
+            <a:r>
+              <a:t>Change data only: edit the chart data table or regenerate from Python.</a:t>
+            </a:r>
+          </a:p>
+          <a:p>
+            <a:pPr>
+              <a:defRPr sz="1100">
+                <a:solidFill>
+                  <a:srgbClr val="2D3741"/>
+                </a:solidFill>
+              </a:defRPr>
+            </a:pPr>
+            <a:r>
+              <a:t>Generated chart image slot: {{chart_image}}</a:t>
+            </a:r>
+          </a:p>
+          <a:p>
+            <a:pPr>
+              <a:defRPr sz="1100">
+                <a:solidFill>
+                  <a:srgbClr val="2D3741"/>
+                </a:solidFill>
+              </a:defRPr>
+            </a:pPr>
+            <a:r>
+              <a:t>Calculated table reference: {{calculated_table}}</a:t>
+            </a:r>
+          </a:p>
+          <a:p>
+            <a:pPr>
+              <a:defRPr sz="1100">
+                <a:solidFill>
+                  <a:srgbClr val="2D3741"/>
+                </a:solidFill>
+              </a:defRPr>
+            </a:pPr>
+            <a:r>
+              <a:t>Caption from evidence package: {{caption}}</a:t>
+            </a:r>
+          </a:p>
+          <a:p>
+            <a:pPr>
+              <a:defRPr sz="1100">
+                <a:solidFill>
+                  <a:srgbClr val="2D3741"/>
+                </a:solidFill>
+              </a:defRPr>
+            </a:pPr>
+            <a:r>
+              <a:t>Data context and filters: {{data_context}}</a:t>
+            </a:r>
+          </a:p>
+          <a:p>
+            <a:pPr>
+              <a:defRPr sz="1100">
+                <a:solidFill>
+                  <a:srgbClr val="2D3741"/>
+                </a:solidFill>
+              </a:defRPr>
+            </a:pPr>
+            <a:r>
+              <a:t>Warnings and cautions: {{warnings}}</a:t>
+            </a:r>
+          </a:p>
+        </p:txBody>
+      </p:sp>
+      <p:sp>
+        <p:nvSpPr>
+          <p:cNvPr id="7" name="Rounded Rectangle 6"/>
+          <p:cNvSpPr/>
+          <p:nvPr/>
+        </p:nvSpPr>
+        <p:spPr>
+          <a:xfrm>
+            <a:off x="6355080" y="1691640"/>
+            <a:ext cx="4892040" cy="4206240"/>
+          </a:xfrm>
+          <a:prstGeom prst="roundRect">
+            <a:avLst/>
+          </a:prstGeom>
+          <a:solidFill>
+            <a:srgbClr val="F8F9F7"/>
+          </a:solidFill>
+          <a:ln>
+            <a:solidFill>
+              <a:srgbClr val="BEC4BF"/>
+            </a:solidFill>
+          </a:ln>
+        </p:spPr>
+        <p:style>
+          <a:lnRef idx="1">
+            <a:schemeClr val="accent1"/>
+          </a:lnRef>
+          <a:fillRef idx="3">
+            <a:schemeClr val="accent1"/>
+          </a:fillRef>
+          <a:effectRef idx="2">
+            <a:schemeClr val="accent1"/>
+          </a:effectRef>
+          <a:fontRef idx="minor">
+            <a:schemeClr val="lt1"/>
+          </a:fontRef>
+        </p:style>
+        <p:txBody>
+          <a:bodyPr rtlCol="0" anchor="t" lIns="164592" rIns="164592" tIns="128016"/>
+          <a:lstStyle/>
+          <a:p>
+            <a:pPr algn="ctr"/>
+            <a:r>
+              <a:rPr b="1" sz="1500">
+                <a:solidFill>
+                  <a:srgbClr val="1B2733"/>
+                </a:solidFill>
+              </a:rPr>
+              <a:t>Reserved placeholders</a:t>
+            </a:r>
+          </a:p>
+          <a:p>
+            <a:pPr>
+              <a:defRPr sz="1100">
+                <a:solidFill>
+                  <a:srgbClr val="2D3741"/>
+                </a:solidFill>
+              </a:defRPr>
+            </a:pPr>
+            <a:r>
+              <a:t>{{method_name}}</a:t>
+            </a:r>
+          </a:p>
+          <a:p>
+            <a:pPr>
+              <a:defRPr sz="1100">
+                <a:solidFill>
+                  <a:srgbClr val="2D3741"/>
+                </a:solidFill>
+              </a:defRPr>
+            </a:pPr>
+            <a:r>
+              <a:t>{{qcc_stage}}</a:t>
+            </a:r>
+          </a:p>
+          <a:p>
+            <a:pPr>
+              <a:defRPr sz="1100">
+                <a:solidFill>
+                  <a:srgbClr val="2D3741"/>
+                </a:solidFill>
+              </a:defRPr>
+            </a:pPr>
+            <a:r>
+              <a:t>{{demo_label}}</a:t>
+            </a:r>
+          </a:p>
+          <a:p>
+            <a:pPr>
+              <a:defRPr sz="1100">
+                <a:solidFill>
+                  <a:srgbClr val="2D3741"/>
+                </a:solidFill>
+              </a:defRPr>
+            </a:pPr>
+            <a:r>
+              <a:t>{{chart_image}}</a:t>
+            </a:r>
+          </a:p>
+          <a:p>
+            <a:pPr>
+              <a:defRPr sz="1100">
+                <a:solidFill>
+                  <a:srgbClr val="2D3741"/>
+                </a:solidFill>
+              </a:defRPr>
+            </a:pPr>
+            <a:r>
+              <a:t>{{calculated_table}}</a:t>
+            </a:r>
+          </a:p>
+          <a:p>
+            <a:pPr>
+              <a:defRPr sz="1100">
+                <a:solidFill>
+                  <a:srgbClr val="2D3741"/>
+                </a:solidFill>
+              </a:defRPr>
+            </a:pPr>
+            <a:r>
+              <a:t>{{caption}}</a:t>
+            </a:r>
+          </a:p>
+          <a:p>
+            <a:pPr>
+              <a:defRPr sz="1100">
+                <a:solidFill>
+                  <a:srgbClr val="2D3741"/>
+                </a:solidFill>
+              </a:defRPr>
+            </a:pPr>
+            <a:r>
+              <a:t>{{data_context}}</a:t>
+            </a:r>
+          </a:p>
+          <a:p>
+            <a:pPr>
+              <a:defRPr sz="1100">
+                <a:solidFill>
+                  <a:srgbClr val="2D3741"/>
+                </a:solidFill>
+              </a:defRPr>
+            </a:pPr>
+            <a:r>
+              <a:t>{{warnings}}</a:t>
+            </a:r>
+          </a:p>
+        </p:txBody>
+      </p:sp>
+      <p:sp>
+        <p:nvSpPr>
+          <p:cNvPr id="8" name="TextBox 7"/>
+          <p:cNvSpPr txBox="1"/>
+          <p:nvPr/>
+        </p:nvSpPr>
+        <p:spPr>
+          <a:xfrm>
+            <a:off x="548640" y="6355080"/>
+            <a:ext cx="10881360" cy="228600"/>
+          </a:xfrm>
+          <a:prstGeom prst="rect">
+            <a:avLst/>
+          </a:prstGeom>
+          <a:noFill/>
+        </p:spPr>
+        <p:txBody>
+          <a:bodyPr wrap="square" lIns="73152" rIns="73152">
+            <a:spAutoFit/>
+          </a:bodyPr>
+          <a:lstStyle/>
+          <a:p>
+            <a:r>
+              <a:rPr sz="800" b="0">
+                <a:solidFill>
+                  <a:srgbClr val="697077"/>
+                </a:solidFill>
+              </a:rPr>
+              <a:t>pareto_chart_method_template | pareto_chart | Final data-dependent evidence belongs in the evidence package.</a:t>
+            </a:r>
+          </a:p>
+        </p:txBody>
+      </p:sp>
+    </p:spTree>
+  </p:cSld>
+  <p:clrMapOvr>
+    <a:masterClrMapping/>
+  </p:clrMapOvr>
+</p:sld>
+</file>
+
+<file path=ppt/slides/slide13.xml><?xml version="1.0" encoding="utf-8"?>
 <p:sld xmlns:a="http://schemas.openxmlformats.org/drawingml/2006/main" xmlns:p="http://schemas.openxmlformats.org/presentationml/2006/main" xmlns:r="http://schemas.openxmlformats.org/officeDocument/2006/relationships">
   <p:cSld>
     <p:spTree>
@@ -5897,7 +7263,7 @@
                   <a:srgbClr val="1B2733"/>
                 </a:solidFill>
               </a:rPr>
-              <a:t>Interpretation patterns and common mistakes</a:t>
+              <a:t>Chart decision guide</a:t>
             </a:r>
           </a:p>
         </p:txBody>
@@ -6026,55 +7392,43 @@
                   <a:srgbClr val="1B2733"/>
                 </a:solidFill>
               </a:rPr>
-              <a:t>Interpretation patterns</a:t>
-            </a:r>
-          </a:p>
-          <a:p>
-            <a:pPr>
-              <a:defRPr sz="1100">
-                <a:solidFill>
-                  <a:srgbClr val="2D3741"/>
-                </a:solidFill>
-              </a:defRPr>
-            </a:pPr>
-            <a:r>
-              <a:t>Largest contributor: name the top category and count.</a:t>
-            </a:r>
-          </a:p>
-          <a:p>
-            <a:pPr>
-              <a:defRPr sz="1100">
-                <a:solidFill>
-                  <a:srgbClr val="2D3741"/>
-                </a:solidFill>
-              </a:defRPr>
-            </a:pPr>
-            <a:r>
-              <a:t>Top-three share: state combined contribution.</a:t>
-            </a:r>
-          </a:p>
-          <a:p>
-            <a:pPr>
-              <a:defRPr sz="1100">
-                <a:solidFill>
-                  <a:srgbClr val="2D3741"/>
-                </a:solidFill>
-              </a:defRPr>
-            </a:pPr>
-            <a:r>
-              <a:t>Focus decision: name the next method.</a:t>
-            </a:r>
-          </a:p>
-          <a:p>
-            <a:pPr>
-              <a:defRPr sz="1100">
-                <a:solidFill>
-                  <a:srgbClr val="2D3741"/>
-                </a:solidFill>
-              </a:defRPr>
-            </a:pPr>
-            <a:r>
-              <a:t>Caution: Pareto does not prove root cause.</a:t>
+              <a:t>Decision supported</a:t>
+            </a:r>
+          </a:p>
+          <a:p>
+            <a:pPr>
+              <a:defRPr sz="1100">
+                <a:solidFill>
+                  <a:srgbClr val="2D3741"/>
+                </a:solidFill>
+              </a:defRPr>
+            </a:pPr>
+            <a:r>
+              <a:t>Choose the category or vital few for follow-up analysis.</a:t>
+            </a:r>
+          </a:p>
+          <a:p>
+            <a:pPr>
+              <a:defRPr sz="1100">
+                <a:solidFill>
+                  <a:srgbClr val="2D3741"/>
+                </a:solidFill>
+              </a:defRPr>
+            </a:pPr>
+            <a:r>
+              <a:t>Pattern to look for: dominant category, steep drop, or long tail.</a:t>
+            </a:r>
+          </a:p>
+          <a:p>
+            <a:pPr>
+              <a:defRPr sz="1100">
+                <a:solidFill>
+                  <a:srgbClr val="2D3741"/>
+                </a:solidFill>
+              </a:defRPr>
+            </a:pPr>
+            <a:r>
+              <a:t>Next method: Fishbone, 5 Whys, stratification, or containment.</a:t>
             </a:r>
           </a:p>
         </p:txBody>
@@ -6127,67 +7481,43 @@
                   <a:srgbClr val="1B2733"/>
                 </a:solidFill>
               </a:rPr>
-              <a:t>Common mistakes</a:t>
-            </a:r>
-          </a:p>
-          <a:p>
-            <a:pPr>
-              <a:defRPr sz="1100">
-                <a:solidFill>
-                  <a:srgbClr val="2D3741"/>
-                </a:solidFill>
-              </a:defRPr>
-            </a:pPr>
-            <a:r>
-              <a:t>Unsorted bars.</a:t>
-            </a:r>
-          </a:p>
-          <a:p>
-            <a:pPr>
-              <a:defRPr sz="1100">
-                <a:solidFill>
-                  <a:srgbClr val="2D3741"/>
-                </a:solidFill>
-              </a:defRPr>
-            </a:pPr>
-            <a:r>
-              <a:t>Overlapping categories.</a:t>
-            </a:r>
-          </a:p>
-          <a:p>
-            <a:pPr>
-              <a:defRPr sz="1100">
-                <a:solidFill>
-                  <a:srgbClr val="2D3741"/>
-                </a:solidFill>
-              </a:defRPr>
-            </a:pPr>
-            <a:r>
-              <a:t>Mixed time periods.</a:t>
-            </a:r>
-          </a:p>
-          <a:p>
-            <a:pPr>
-              <a:defRPr sz="1100">
-                <a:solidFill>
-                  <a:srgbClr val="2D3741"/>
-                </a:solidFill>
-              </a:defRPr>
-            </a:pPr>
-            <a:r>
-              <a:t>Missing source or date range.</a:t>
-            </a:r>
-          </a:p>
-          <a:p>
-            <a:pPr>
-              <a:defRPr sz="1100">
-                <a:solidFill>
-                  <a:srgbClr val="2D3741"/>
-                </a:solidFill>
-              </a:defRPr>
-            </a:pPr>
-            <a:r>
-              <a:t>Demo data used as project evidence.</a:t>
+              <a:t>Safe conclusion</a:t>
+            </a:r>
+          </a:p>
+          <a:p>
+            <a:pPr>
+              <a:defRPr sz="1100">
+                <a:solidFill>
+                  <a:srgbClr val="2D3741"/>
+                </a:solidFill>
+              </a:defRPr>
+            </a:pPr>
+            <a:r>
+              <a:t>Safe conclusion: counted problems are concentrated here.</a:t>
+            </a:r>
+          </a:p>
+          <a:p>
+            <a:pPr>
+              <a:defRPr sz="1100">
+                <a:solidFill>
+                  <a:srgbClr val="2D3741"/>
+                </a:solidFill>
+              </a:defRPr>
+            </a:pPr>
+            <a:r>
+              <a:t>Overclaim to avoid: Pareto does not prove root cause.</a:t>
+            </a:r>
+          </a:p>
+          <a:p>
+            <a:pPr>
+              <a:defRPr sz="1100">
+                <a:solidFill>
+                  <a:srgbClr val="2D3741"/>
+                </a:solidFill>
+              </a:defRPr>
+            </a:pPr>
+            <a:r>
+              <a:t>Do not claim stable improvement from one Pareto snapshot.</a:t>
             </a:r>
           </a:p>
         </p:txBody>
@@ -6271,7 +7601,7 @@
                   <a:srgbClr val="1B2733"/>
                 </a:solidFill>
               </a:rPr>
-              <a:t>Facilitator checklist and Python assist decision</a:t>
+              <a:t>Chart variant library</a:t>
             </a:r>
           </a:p>
         </p:txBody>
@@ -6352,16 +7682,34 @@
           </a:p>
         </p:txBody>
       </p:sp>
-      <p:sp>
-        <p:nvSpPr>
-          <p:cNvPr id="5" name="Rounded Rectangle 4"/>
+      <p:graphicFrame>
+        <p:nvGraphicFramePr>
+          <p:cNvPr id="5" name="Chart 4"/>
+          <p:cNvGraphicFramePr>
+            <a:graphicFrameLocks noGrp="1"/>
+          </p:cNvGraphicFramePr>
+          <p:nvPr/>
+        </p:nvGraphicFramePr>
+        <p:xfrm>
+          <a:off x="685800" y="1417320"/>
+          <a:ext cx="5303520" cy="2971800"/>
+        </p:xfrm>
+        <a:graphic>
+          <a:graphicData uri="http://schemas.openxmlformats.org/drawingml/2006/chart">
+            <c:chart xmlns:c="http://schemas.openxmlformats.org/drawingml/2006/chart" r:id="rId2"/>
+          </a:graphicData>
+        </a:graphic>
+      </p:graphicFrame>
+      <p:sp>
+        <p:nvSpPr>
+          <p:cNvPr id="6" name="Rounded Rectangle 5"/>
           <p:cNvSpPr/>
           <p:nvPr/>
         </p:nvSpPr>
         <p:spPr>
           <a:xfrm>
-            <a:off x="640080" y="1325880"/>
-            <a:ext cx="5212080" cy="4526280"/>
+            <a:off x="6263640" y="1325880"/>
+            <a:ext cx="5212080" cy="1965960"/>
           </a:xfrm>
           <a:prstGeom prst="roundRect">
             <a:avLst/>
@@ -6400,69 +7748,69 @@
                   <a:srgbClr val="1B2733"/>
                 </a:solidFill>
               </a:rPr>
-              <a:t>Facilitator checklist</a:t>
-            </a:r>
-          </a:p>
-          <a:p>
-            <a:pPr>
-              <a:defRPr sz="1100">
-                <a:solidFill>
-                  <a:srgbClr val="2D3741"/>
-                </a:solidFill>
-              </a:defRPr>
-            </a:pPr>
-            <a:r>
-              <a:t>Source and date range shown.</a:t>
-            </a:r>
-          </a:p>
-          <a:p>
-            <a:pPr>
-              <a:defRPr sz="1100">
-                <a:solidFill>
-                  <a:srgbClr val="2D3741"/>
-                </a:solidFill>
-              </a:defRPr>
-            </a:pPr>
-            <a:r>
-              <a:t>Categories clear and non-overlapping.</a:t>
-            </a:r>
-          </a:p>
-          <a:p>
-            <a:pPr>
-              <a:defRPr sz="1100">
-                <a:solidFill>
-                  <a:srgbClr val="2D3741"/>
-                </a:solidFill>
-              </a:defRPr>
-            </a:pPr>
-            <a:r>
-              <a:t>Counts sorted descending.</a:t>
-            </a:r>
-          </a:p>
-          <a:p>
-            <a:pPr>
-              <a:defRPr sz="1100">
-                <a:solidFill>
-                  <a:srgbClr val="2D3741"/>
-                </a:solidFill>
-              </a:defRPr>
-            </a:pPr>
-            <a:r>
-              <a:t>Conclusion and next action written.</a:t>
-            </a:r>
-          </a:p>
-        </p:txBody>
-      </p:sp>
-      <p:sp>
-        <p:nvSpPr>
-          <p:cNvPr id="6" name="Rounded Rectangle 5"/>
+              <a:t>Pareto variants</a:t>
+            </a:r>
+          </a:p>
+          <a:p>
+            <a:pPr>
+              <a:defRPr sz="1100">
+                <a:solidFill>
+                  <a:srgbClr val="2D3741"/>
+                </a:solidFill>
+              </a:defRPr>
+            </a:pPr>
+            <a:r>
+              <a:t>Simple count Pareto: draft focus decision.</a:t>
+            </a:r>
+          </a:p>
+          <a:p>
+            <a:pPr>
+              <a:defRPr sz="1100">
+                <a:solidFill>
+                  <a:srgbClr val="2D3741"/>
+                </a:solidFill>
+              </a:defRPr>
+            </a:pPr>
+            <a:r>
+              <a:t>Cumulative Pareto: top-share or threshold wording.</a:t>
+            </a:r>
+          </a:p>
+          <a:p>
+            <a:pPr>
+              <a:defRPr sz="1100">
+                <a:solidFill>
+                  <a:srgbClr val="2D3741"/>
+                </a:solidFill>
+              </a:defRPr>
+            </a:pPr>
+            <a:r>
+              <a:t>Before/after Pareto comparison: comparable periods only.</a:t>
+            </a:r>
+          </a:p>
+          <a:p>
+            <a:pPr>
+              <a:defRPr sz="1100">
+                <a:solidFill>
+                  <a:srgbClr val="2D3741"/>
+                </a:solidFill>
+              </a:defRPr>
+            </a:pPr>
+            <a:r>
+              <a:t>Focus annotation: mark selected vital few.</a:t>
+            </a:r>
+          </a:p>
+        </p:txBody>
+      </p:sp>
+      <p:sp>
+        <p:nvSpPr>
+          <p:cNvPr id="7" name="Rounded Rectangle 6"/>
           <p:cNvSpPr/>
           <p:nvPr/>
         </p:nvSpPr>
         <p:spPr>
           <a:xfrm>
-            <a:off x="6263640" y="1325880"/>
-            <a:ext cx="5212080" cy="4526280"/>
+            <a:off x="6263640" y="3520440"/>
+            <a:ext cx="5212080" cy="1691640"/>
           </a:xfrm>
           <a:prstGeom prst="roundRect">
             <a:avLst/>
@@ -6501,62 +7849,115 @@
                   <a:srgbClr val="1B2733"/>
                 </a:solidFill>
               </a:rPr>
-              <a:t>Python assist decision</a:t>
-            </a:r>
-          </a:p>
-          <a:p>
-            <a:pPr>
-              <a:defRPr sz="1100">
-                <a:solidFill>
-                  <a:srgbClr val="2D3741"/>
-                </a:solidFill>
-              </a:defRPr>
-            </a:pPr>
-            <a:r>
-              <a:t>PowerPoint: training, draft, and small counted tables.</a:t>
-            </a:r>
-          </a:p>
-          <a:p>
-            <a:pPr>
-              <a:defRPr sz="1100">
-                <a:solidFill>
-                  <a:srgbClr val="2D3741"/>
-                </a:solidFill>
-              </a:defRPr>
-            </a:pPr>
-            <a:r>
-              <a:t>Python: raw logs, repeated generation, validation-heavy data.</a:t>
-            </a:r>
-          </a:p>
-          <a:p>
-            <a:pPr>
-              <a:defRPr sz="1100">
-                <a:solidFill>
-                  <a:srgbClr val="2D3741"/>
-                </a:solidFill>
-              </a:defRPr>
-            </a:pPr>
-            <a:r>
-              <a:t>Level 3: Python recommended for raw or repeated chart methods.</a:t>
-            </a:r>
-          </a:p>
-          <a:p>
-            <a:pPr>
-              <a:defRPr sz="1100">
-                <a:solidFill>
-                  <a:srgbClr val="2D3741"/>
-                </a:solidFill>
-              </a:defRPr>
-            </a:pPr>
-            <a:r>
-              <a:t>Level 4: reproducible evidence package or validated path.</a:t>
-            </a:r>
-          </a:p>
-        </p:txBody>
-      </p:sp>
-      <p:sp>
-        <p:nvSpPr>
-          <p:cNvPr id="7" name="TextBox 6"/>
+              <a:t>When to use Python assist</a:t>
+            </a:r>
+          </a:p>
+          <a:p>
+            <a:pPr>
+              <a:defRPr sz="1100">
+                <a:solidFill>
+                  <a:srgbClr val="2D3741"/>
+                </a:solidFill>
+              </a:defRPr>
+            </a:pPr>
+            <a:r>
+              <a:t>Raw logs or repeated generation.</a:t>
+            </a:r>
+          </a:p>
+          <a:p>
+            <a:pPr>
+              <a:defRPr sz="1100">
+                <a:solidFill>
+                  <a:srgbClr val="2D3741"/>
+                </a:solidFill>
+              </a:defRPr>
+            </a:pPr>
+            <a:r>
+              <a:t>Validation-heavy data or many categories.</a:t>
+            </a:r>
+          </a:p>
+          <a:p>
+            <a:pPr>
+              <a:defRPr sz="1100">
+                <a:solidFill>
+                  <a:srgbClr val="2D3741"/>
+                </a:solidFill>
+              </a:defRPr>
+            </a:pPr>
+            <a:r>
+              <a:t>Final reviewed evidence needing metadata.</a:t>
+            </a:r>
+          </a:p>
+        </p:txBody>
+      </p:sp>
+      <p:sp>
+        <p:nvSpPr>
+          <p:cNvPr id="8" name="Rounded Rectangle 7"/>
+          <p:cNvSpPr/>
+          <p:nvPr/>
+        </p:nvSpPr>
+        <p:spPr>
+          <a:xfrm>
+            <a:off x="685800" y="4754880"/>
+            <a:ext cx="5303520" cy="822960"/>
+          </a:xfrm>
+          <a:prstGeom prst="roundRect">
+            <a:avLst/>
+          </a:prstGeom>
+          <a:solidFill>
+            <a:srgbClr val="F8F9F7"/>
+          </a:solidFill>
+          <a:ln>
+            <a:solidFill>
+              <a:srgbClr val="BEC4BF"/>
+            </a:solidFill>
+          </a:ln>
+        </p:spPr>
+        <p:style>
+          <a:lnRef idx="1">
+            <a:schemeClr val="accent1"/>
+          </a:lnRef>
+          <a:fillRef idx="3">
+            <a:schemeClr val="accent1"/>
+          </a:fillRef>
+          <a:effectRef idx="2">
+            <a:schemeClr val="accent1"/>
+          </a:effectRef>
+          <a:fontRef idx="minor">
+            <a:schemeClr val="lt1"/>
+          </a:fontRef>
+        </p:style>
+        <p:txBody>
+          <a:bodyPr rtlCol="0" anchor="t" lIns="164592" rIns="164592" tIns="128016"/>
+          <a:lstStyle/>
+          <a:p>
+            <a:pPr algn="ctr"/>
+            <a:r>
+              <a:rPr b="1" sz="1500">
+                <a:solidFill>
+                  <a:srgbClr val="1B2733"/>
+                </a:solidFill>
+              </a:rPr>
+              <a:t>Focus annotation</a:t>
+            </a:r>
+          </a:p>
+          <a:p>
+            <a:pPr>
+              <a:defRPr sz="1100">
+                <a:solidFill>
+                  <a:srgbClr val="2D3741"/>
+                </a:solidFill>
+              </a:defRPr>
+            </a:pPr>
+            <a:r>
+              <a:t>Call out the selected vital few and the next method.</a:t>
+            </a:r>
+          </a:p>
+        </p:txBody>
+      </p:sp>
+      <p:sp>
+        <p:nvSpPr>
+          <p:cNvPr id="9" name="TextBox 8"/>
           <p:cNvSpPr txBox="1"/>
           <p:nvPr/>
         </p:nvSpPr>
@@ -6633,7 +8034,7 @@
                   <a:srgbClr val="1B2733"/>
                 </a:solidFill>
               </a:rPr>
-              <a:t>Evidence/source note</a:t>
+              <a:t>Chart quality checklist</a:t>
             </a:r>
           </a:p>
         </p:txBody>
@@ -6762,55 +8163,79 @@
                   <a:srgbClr val="1B2733"/>
                 </a:solidFill>
               </a:rPr>
-              <a:t>Evidence levels</a:t>
-            </a:r>
-          </a:p>
-          <a:p>
-            <a:pPr>
-              <a:defRPr sz="1100">
-                <a:solidFill>
-                  <a:srgbClr val="2D3741"/>
-                </a:solidFill>
-              </a:defRPr>
-            </a:pPr>
-            <a:r>
-              <a:t>Level 1: teaching/draft PowerPoint edits.</a:t>
-            </a:r>
-          </a:p>
-          <a:p>
-            <a:pPr>
-              <a:defRPr sz="1100">
-                <a:solidFill>
-                  <a:srgbClr val="2D3741"/>
-                </a:solidFill>
-              </a:defRPr>
-            </a:pPr>
-            <a:r>
-              <a:t>Level 2: normal project with source and checklist evidence.</a:t>
-            </a:r>
-          </a:p>
-          <a:p>
-            <a:pPr>
-              <a:defRPr sz="1100">
-                <a:solidFill>
-                  <a:srgbClr val="2D3741"/>
-                </a:solidFill>
-              </a:defRPr>
-            </a:pPr>
-            <a:r>
-              <a:t>Level 3: formal review with source data and calculation table.</a:t>
-            </a:r>
-          </a:p>
-          <a:p>
-            <a:pPr>
-              <a:defRPr sz="1100">
-                <a:solidFill>
-                  <a:srgbClr val="2D3741"/>
-                </a:solidFill>
-              </a:defRPr>
-            </a:pPr>
-            <a:r>
-              <a:t>Level 4: audit/high-risk reproducible evidence.</a:t>
+              <a:t>Chart fields</a:t>
+            </a:r>
+          </a:p>
+          <a:p>
+            <a:pPr>
+              <a:defRPr sz="1100">
+                <a:solidFill>
+                  <a:srgbClr val="2D3741"/>
+                </a:solidFill>
+              </a:defRPr>
+            </a:pPr>
+            <a:r>
+              <a:t>Source.</a:t>
+            </a:r>
+          </a:p>
+          <a:p>
+            <a:pPr>
+              <a:defRPr sz="1100">
+                <a:solidFill>
+                  <a:srgbClr val="2D3741"/>
+                </a:solidFill>
+              </a:defRPr>
+            </a:pPr>
+            <a:r>
+              <a:t>Date range.</a:t>
+            </a:r>
+          </a:p>
+          <a:p>
+            <a:pPr>
+              <a:defRPr sz="1100">
+                <a:solidFill>
+                  <a:srgbClr val="2D3741"/>
+                </a:solidFill>
+              </a:defRPr>
+            </a:pPr>
+            <a:r>
+              <a:t>Filters.</a:t>
+            </a:r>
+          </a:p>
+          <a:p>
+            <a:pPr>
+              <a:defRPr sz="1100">
+                <a:solidFill>
+                  <a:srgbClr val="2D3741"/>
+                </a:solidFill>
+              </a:defRPr>
+            </a:pPr>
+            <a:r>
+              <a:t>Percent.</a:t>
+            </a:r>
+          </a:p>
+          <a:p>
+            <a:pPr>
+              <a:defRPr sz="1100">
+                <a:solidFill>
+                  <a:srgbClr val="2D3741"/>
+                </a:solidFill>
+              </a:defRPr>
+            </a:pPr>
+            <a:r>
+              <a:t>Cumulative percent.</a:t>
+            </a:r>
+          </a:p>
+          <a:p>
+            <a:pPr>
+              <a:defRPr sz="1100">
+                <a:solidFill>
+                  <a:srgbClr val="2D3741"/>
+                </a:solidFill>
+              </a:defRPr>
+            </a:pPr>
+            <a:r>
+              <a:t>Formula check.</a:t>
             </a:r>
           </a:p>
         </p:txBody>
@@ -6863,67 +8288,67 @@
                   <a:srgbClr val="1B2733"/>
                 </a:solidFill>
               </a:rPr>
-              <a:t>Record on the slide</a:t>
-            </a:r>
-          </a:p>
-          <a:p>
-            <a:pPr>
-              <a:defRPr sz="1100">
-                <a:solidFill>
-                  <a:srgbClr val="2D3741"/>
-                </a:solidFill>
-              </a:defRPr>
-            </a:pPr>
-            <a:r>
-              <a:t>Source.</a:t>
-            </a:r>
-          </a:p>
-          <a:p>
-            <a:pPr>
-              <a:defRPr sz="1100">
-                <a:solidFill>
-                  <a:srgbClr val="2D3741"/>
-                </a:solidFill>
-              </a:defRPr>
-            </a:pPr>
-            <a:r>
-              <a:t>Date range.</a:t>
-            </a:r>
-          </a:p>
-          <a:p>
-            <a:pPr>
-              <a:defRPr sz="1100">
-                <a:solidFill>
-                  <a:srgbClr val="2D3741"/>
-                </a:solidFill>
-              </a:defRPr>
-            </a:pPr>
-            <a:r>
-              <a:t>Filters and assumptions.</a:t>
-            </a:r>
-          </a:p>
-          <a:p>
-            <a:pPr>
-              <a:defRPr sz="1100">
-                <a:solidFill>
-                  <a:srgbClr val="2D3741"/>
-                </a:solidFill>
-              </a:defRPr>
-            </a:pPr>
-            <a:r>
-              <a:t>Calculation notes.</a:t>
-            </a:r>
-          </a:p>
-          <a:p>
-            <a:pPr>
-              <a:defRPr sz="1100">
-                <a:solidFill>
-                  <a:srgbClr val="2D3741"/>
-                </a:solidFill>
-              </a:defRPr>
-            </a:pPr>
-            <a:r>
-              <a:t>Prepared by/date.</a:t>
+              <a:t>Reviewer checks</a:t>
+            </a:r>
+          </a:p>
+          <a:p>
+            <a:pPr>
+              <a:defRPr sz="1100">
+                <a:solidFill>
+                  <a:srgbClr val="2D3741"/>
+                </a:solidFill>
+              </a:defRPr>
+            </a:pPr>
+            <a:r>
+              <a:t>Bars sorted descending.</a:t>
+            </a:r>
+          </a:p>
+          <a:p>
+            <a:pPr>
+              <a:defRPr sz="1100">
+                <a:solidFill>
+                  <a:srgbClr val="2D3741"/>
+                </a:solidFill>
+              </a:defRPr>
+            </a:pPr>
+            <a:r>
+              <a:t>Category definitions are clear.</a:t>
+            </a:r>
+          </a:p>
+          <a:p>
+            <a:pPr>
+              <a:defRPr sz="1100">
+                <a:solidFill>
+                  <a:srgbClr val="2D3741"/>
+                </a:solidFill>
+              </a:defRPr>
+            </a:pPr>
+            <a:r>
+              <a:t>Labels and counts are readable.</a:t>
+            </a:r>
+          </a:p>
+          <a:p>
+            <a:pPr>
+              <a:defRPr sz="1100">
+                <a:solidFill>
+                  <a:srgbClr val="2D3741"/>
+                </a:solidFill>
+              </a:defRPr>
+            </a:pPr>
+            <a:r>
+              <a:t>Formula cells were not overwritten.</a:t>
+            </a:r>
+          </a:p>
+          <a:p>
+            <a:pPr>
+              <a:defRPr sz="1100">
+                <a:solidFill>
+                  <a:srgbClr val="2D3741"/>
+                </a:solidFill>
+              </a:defRPr>
+            </a:pPr>
+            <a:r>
+              <a:t>Key finding and next action are written.</a:t>
             </a:r>
           </a:p>
         </p:txBody>
@@ -7007,7 +8432,7 @@
                   <a:srgbClr val="1B2733"/>
                 </a:solidFill>
               </a:rPr>
-              <a:t>Completed demo example - DEMO EXAMPLE - not project evidence</a:t>
+              <a:t>Interpretation patterns and common mistakes</a:t>
             </a:r>
           </a:p>
         </p:txBody>
@@ -7096,61 +8521,8 @@
         </p:nvSpPr>
         <p:spPr>
           <a:xfrm>
-            <a:off x="640080" y="1051560"/>
-            <a:ext cx="3840480" cy="329184"/>
-          </a:xfrm>
-          <a:prstGeom prst="roundRect">
-            <a:avLst/>
-          </a:prstGeom>
-          <a:solidFill>
-            <a:srgbClr val="FFF2CC"/>
-          </a:solidFill>
-          <a:ln>
-            <a:solidFill>
-              <a:srgbClr val="D69F2E"/>
-            </a:solidFill>
-          </a:ln>
-        </p:spPr>
-        <p:style>
-          <a:lnRef idx="1">
-            <a:schemeClr val="accent1"/>
-          </a:lnRef>
-          <a:fillRef idx="3">
-            <a:schemeClr val="accent1"/>
-          </a:fillRef>
-          <a:effectRef idx="2">
-            <a:schemeClr val="accent1"/>
-          </a:effectRef>
-          <a:fontRef idx="minor">
-            <a:schemeClr val="lt1"/>
-          </a:fontRef>
-        </p:style>
-        <p:txBody>
-          <a:bodyPr rtlCol="0" anchor="ctr"/>
-          <a:lstStyle/>
-          <a:p>
-            <a:pPr algn="ctr"/>
-            <a:r>
-              <a:rPr b="1" sz="1100">
-                <a:solidFill>
-                  <a:srgbClr val="664B11"/>
-                </a:solidFill>
-              </a:rPr>
-              <a:t>DEMO EXAMPLE - not project evidence</a:t>
-            </a:r>
-          </a:p>
-        </p:txBody>
-      </p:sp>
-      <p:sp>
-        <p:nvSpPr>
-          <p:cNvPr id="6" name="Rounded Rectangle 5"/>
-          <p:cNvSpPr/>
-          <p:nvPr/>
-        </p:nvSpPr>
-        <p:spPr>
-          <a:xfrm>
-            <a:off x="640080" y="1691640"/>
-            <a:ext cx="5394960" cy="4206240"/>
+            <a:off x="640080" y="1325880"/>
+            <a:ext cx="5212080" cy="4526280"/>
           </a:xfrm>
           <a:prstGeom prst="roundRect">
             <a:avLst/>
@@ -7189,93 +8561,69 @@
                   <a:srgbClr val="1B2733"/>
                 </a:solidFill>
               </a:rPr>
-              <a:t>Demo structure</a:t>
-            </a:r>
-          </a:p>
-          <a:p>
-            <a:pPr>
-              <a:defRPr sz="1100">
-                <a:solidFill>
-                  <a:srgbClr val="2D3741"/>
-                </a:solidFill>
-              </a:defRPr>
-            </a:pPr>
-            <a:r>
-              <a:t>Change data only: edit the chart data table or regenerate from Python.</a:t>
-            </a:r>
-          </a:p>
-          <a:p>
-            <a:pPr>
-              <a:defRPr sz="1100">
-                <a:solidFill>
-                  <a:srgbClr val="2D3741"/>
-                </a:solidFill>
-              </a:defRPr>
-            </a:pPr>
-            <a:r>
-              <a:t>Generated chart image slot: {{chart_image}}</a:t>
-            </a:r>
-          </a:p>
-          <a:p>
-            <a:pPr>
-              <a:defRPr sz="1100">
-                <a:solidFill>
-                  <a:srgbClr val="2D3741"/>
-                </a:solidFill>
-              </a:defRPr>
-            </a:pPr>
-            <a:r>
-              <a:t>Calculated table reference: {{calculated_table}}</a:t>
-            </a:r>
-          </a:p>
-          <a:p>
-            <a:pPr>
-              <a:defRPr sz="1100">
-                <a:solidFill>
-                  <a:srgbClr val="2D3741"/>
-                </a:solidFill>
-              </a:defRPr>
-            </a:pPr>
-            <a:r>
-              <a:t>Caption from evidence package: {{caption}}</a:t>
-            </a:r>
-          </a:p>
-          <a:p>
-            <a:pPr>
-              <a:defRPr sz="1100">
-                <a:solidFill>
-                  <a:srgbClr val="2D3741"/>
-                </a:solidFill>
-              </a:defRPr>
-            </a:pPr>
-            <a:r>
-              <a:t>Data context and filters: {{data_context}}</a:t>
-            </a:r>
-          </a:p>
-          <a:p>
-            <a:pPr>
-              <a:defRPr sz="1100">
-                <a:solidFill>
-                  <a:srgbClr val="2D3741"/>
-                </a:solidFill>
-              </a:defRPr>
-            </a:pPr>
-            <a:r>
-              <a:t>Warnings and cautions: {{warnings}}</a:t>
-            </a:r>
-          </a:p>
-        </p:txBody>
-      </p:sp>
-      <p:sp>
-        <p:nvSpPr>
-          <p:cNvPr id="7" name="Rounded Rectangle 6"/>
+              <a:t>Interpretation patterns</a:t>
+            </a:r>
+          </a:p>
+          <a:p>
+            <a:pPr>
+              <a:defRPr sz="1100">
+                <a:solidFill>
+                  <a:srgbClr val="2D3741"/>
+                </a:solidFill>
+              </a:defRPr>
+            </a:pPr>
+            <a:r>
+              <a:t>Largest contributor: name the top category and count.</a:t>
+            </a:r>
+          </a:p>
+          <a:p>
+            <a:pPr>
+              <a:defRPr sz="1100">
+                <a:solidFill>
+                  <a:srgbClr val="2D3741"/>
+                </a:solidFill>
+              </a:defRPr>
+            </a:pPr>
+            <a:r>
+              <a:t>Top-three share: state combined contribution.</a:t>
+            </a:r>
+          </a:p>
+          <a:p>
+            <a:pPr>
+              <a:defRPr sz="1100">
+                <a:solidFill>
+                  <a:srgbClr val="2D3741"/>
+                </a:solidFill>
+              </a:defRPr>
+            </a:pPr>
+            <a:r>
+              <a:t>Focus decision: name the next method.</a:t>
+            </a:r>
+          </a:p>
+          <a:p>
+            <a:pPr>
+              <a:defRPr sz="1100">
+                <a:solidFill>
+                  <a:srgbClr val="2D3741"/>
+                </a:solidFill>
+              </a:defRPr>
+            </a:pPr>
+            <a:r>
+              <a:t>Caution: Pareto does not prove root cause.</a:t>
+            </a:r>
+          </a:p>
+        </p:txBody>
+      </p:sp>
+      <p:sp>
+        <p:nvSpPr>
+          <p:cNvPr id="6" name="Rounded Rectangle 5"/>
           <p:cNvSpPr/>
           <p:nvPr/>
         </p:nvSpPr>
         <p:spPr>
           <a:xfrm>
-            <a:off x="6355080" y="1691640"/>
-            <a:ext cx="4892040" cy="4206240"/>
+            <a:off x="6263640" y="1325880"/>
+            <a:ext cx="5212080" cy="4526280"/>
           </a:xfrm>
           <a:prstGeom prst="roundRect">
             <a:avLst/>
@@ -7314,110 +8662,74 @@
                   <a:srgbClr val="1B2733"/>
                 </a:solidFill>
               </a:rPr>
-              <a:t>Reserved placeholders</a:t>
-            </a:r>
-          </a:p>
-          <a:p>
-            <a:pPr>
-              <a:defRPr sz="1100">
-                <a:solidFill>
-                  <a:srgbClr val="2D3741"/>
-                </a:solidFill>
-              </a:defRPr>
-            </a:pPr>
-            <a:r>
-              <a:t>{{method_name}}</a:t>
-            </a:r>
-          </a:p>
-          <a:p>
-            <a:pPr>
-              <a:defRPr sz="1100">
-                <a:solidFill>
-                  <a:srgbClr val="2D3741"/>
-                </a:solidFill>
-              </a:defRPr>
-            </a:pPr>
-            <a:r>
-              <a:t>{{qcc_stage}}</a:t>
-            </a:r>
-          </a:p>
-          <a:p>
-            <a:pPr>
-              <a:defRPr sz="1100">
-                <a:solidFill>
-                  <a:srgbClr val="2D3741"/>
-                </a:solidFill>
-              </a:defRPr>
-            </a:pPr>
-            <a:r>
-              <a:t>{{demo_label}}</a:t>
-            </a:r>
-          </a:p>
-          <a:p>
-            <a:pPr>
-              <a:defRPr sz="1100">
-                <a:solidFill>
-                  <a:srgbClr val="2D3741"/>
-                </a:solidFill>
-              </a:defRPr>
-            </a:pPr>
-            <a:r>
-              <a:t>{{chart_image}}</a:t>
-            </a:r>
-          </a:p>
-          <a:p>
-            <a:pPr>
-              <a:defRPr sz="1100">
-                <a:solidFill>
-                  <a:srgbClr val="2D3741"/>
-                </a:solidFill>
-              </a:defRPr>
-            </a:pPr>
-            <a:r>
-              <a:t>{{calculated_table}}</a:t>
-            </a:r>
-          </a:p>
-          <a:p>
-            <a:pPr>
-              <a:defRPr sz="1100">
-                <a:solidFill>
-                  <a:srgbClr val="2D3741"/>
-                </a:solidFill>
-              </a:defRPr>
-            </a:pPr>
-            <a:r>
-              <a:t>{{caption}}</a:t>
-            </a:r>
-          </a:p>
-          <a:p>
-            <a:pPr>
-              <a:defRPr sz="1100">
-                <a:solidFill>
-                  <a:srgbClr val="2D3741"/>
-                </a:solidFill>
-              </a:defRPr>
-            </a:pPr>
-            <a:r>
-              <a:t>{{data_context}}</a:t>
-            </a:r>
-          </a:p>
-          <a:p>
-            <a:pPr>
-              <a:defRPr sz="1100">
-                <a:solidFill>
-                  <a:srgbClr val="2D3741"/>
-                </a:solidFill>
-              </a:defRPr>
-            </a:pPr>
-            <a:r>
-              <a:t>{{warnings}}</a:t>
-            </a:r>
-          </a:p>
-        </p:txBody>
-      </p:sp>
-      <p:sp>
-        <p:nvSpPr>
-          <p:cNvPr id="8" name="TextBox 7"/>
+              <a:t>Common mistakes</a:t>
+            </a:r>
+          </a:p>
+          <a:p>
+            <a:pPr>
+              <a:defRPr sz="1100">
+                <a:solidFill>
+                  <a:srgbClr val="2D3741"/>
+                </a:solidFill>
+              </a:defRPr>
+            </a:pPr>
+            <a:r>
+              <a:t>Unsorted bars.</a:t>
+            </a:r>
+          </a:p>
+          <a:p>
+            <a:pPr>
+              <a:defRPr sz="1100">
+                <a:solidFill>
+                  <a:srgbClr val="2D3741"/>
+                </a:solidFill>
+              </a:defRPr>
+            </a:pPr>
+            <a:r>
+              <a:t>Overlapping categories.</a:t>
+            </a:r>
+          </a:p>
+          <a:p>
+            <a:pPr>
+              <a:defRPr sz="1100">
+                <a:solidFill>
+                  <a:srgbClr val="2D3741"/>
+                </a:solidFill>
+              </a:defRPr>
+            </a:pPr>
+            <a:r>
+              <a:t>Mixed time periods.</a:t>
+            </a:r>
+          </a:p>
+          <a:p>
+            <a:pPr>
+              <a:defRPr sz="1100">
+                <a:solidFill>
+                  <a:srgbClr val="2D3741"/>
+                </a:solidFill>
+              </a:defRPr>
+            </a:pPr>
+            <a:r>
+              <a:t>Missing source or date range.</a:t>
+            </a:r>
+          </a:p>
+          <a:p>
+            <a:pPr>
+              <a:defRPr sz="1100">
+                <a:solidFill>
+                  <a:srgbClr val="2D3741"/>
+                </a:solidFill>
+              </a:defRPr>
+            </a:pPr>
+            <a:r>
+              <a:t>Demo data used as project evidence.</a:t>
+            </a:r>
+          </a:p>
+        </p:txBody>
+      </p:sp>
+      <p:sp>
+        <p:nvSpPr>
+          <p:cNvPr id="7" name="TextBox 6"/>
           <p:cNvSpPr txBox="1"/>
           <p:nvPr/>
         </p:nvSpPr>

</xml_diff>